<commit_message>
added binomial distribution graph
</commit_message>
<xml_diff>
--- a/statistics_05_hypothesis_testing_p_val.pptx
+++ b/statistics_05_hypothesis_testing_p_val.pptx
@@ -5,17 +5,18 @@
     <p:sldMasterId id="2147483659" r:id="rId1"/>
   </p:sldMasterIdLst>
   <p:notesMasterIdLst>
-    <p:notesMasterId r:id="rId10"/>
+    <p:notesMasterId r:id="rId11"/>
   </p:notesMasterIdLst>
   <p:sldIdLst>
     <p:sldId id="316" r:id="rId2"/>
     <p:sldId id="258" r:id="rId3"/>
     <p:sldId id="259" r:id="rId4"/>
     <p:sldId id="317" r:id="rId5"/>
-    <p:sldId id="314" r:id="rId6"/>
-    <p:sldId id="315" r:id="rId7"/>
-    <p:sldId id="313" r:id="rId8"/>
-    <p:sldId id="294" r:id="rId9"/>
+    <p:sldId id="318" r:id="rId6"/>
+    <p:sldId id="314" r:id="rId7"/>
+    <p:sldId id="315" r:id="rId8"/>
+    <p:sldId id="313" r:id="rId9"/>
+    <p:sldId id="294" r:id="rId10"/>
   </p:sldIdLst>
   <p:sldSz cx="12192000" cy="6858000"/>
   <p:notesSz cx="6858000" cy="9144000"/>
@@ -17553,8 +17554,8 @@
         </p:nvSpPr>
         <p:spPr>
           <a:xfrm>
-            <a:off x="6076666" y="1704583"/>
-            <a:ext cx="5827594" cy="5047536"/>
+            <a:off x="6128885" y="2886495"/>
+            <a:ext cx="5885365" cy="1015663"/>
           </a:xfrm>
           <a:prstGeom prst="rect">
             <a:avLst/>
@@ -17568,360 +17569,162 @@
           <a:lstStyle/>
           <a:p>
             <a:r>
-              <a:rPr lang="en-US" b="1" dirty="0">
+              <a:rPr lang="en-US" sz="1200" b="1" dirty="0" err="1">
                 <a:solidFill>
                   <a:srgbClr val="0070C0"/>
                 </a:solidFill>
                 <a:latin typeface="Consolas" panose="020B0609020204030204" pitchFamily="49" charset="0"/>
                 <a:cs typeface="Consolas" panose="020B0609020204030204" pitchFamily="49" charset="0"/>
               </a:rPr>
-              <a:t># </a:t>
-            </a:r>
-            <a:r>
-              <a:rPr lang="en-US" b="1" dirty="0" err="1">
-                <a:solidFill>
-                  <a:srgbClr val="FF0000"/>
+              <a:t>binom_test</a:t>
+            </a:r>
+            <a:r>
+              <a:rPr lang="en-US" sz="1200" b="1" dirty="0">
+                <a:solidFill>
+                  <a:srgbClr val="0070C0"/>
                 </a:solidFill>
                 <a:latin typeface="Consolas" panose="020B0609020204030204" pitchFamily="49" charset="0"/>
                 <a:cs typeface="Consolas" panose="020B0609020204030204" pitchFamily="49" charset="0"/>
               </a:rPr>
-              <a:t>scipy.stats.binom_test</a:t>
-            </a:r>
-            <a:r>
-              <a:rPr lang="en-US" b="1" dirty="0">
-                <a:solidFill>
-                  <a:srgbClr val="FF0000"/>
+              <a:t>(x=0,   n=1000, p=1/2, alternative='less')  </a:t>
+            </a:r>
+            <a:r>
+              <a:rPr lang="en-US" sz="1200" b="1" dirty="0">
+                <a:solidFill>
+                  <a:srgbClr val="00B050"/>
                 </a:solidFill>
                 <a:latin typeface="Consolas" panose="020B0609020204030204" pitchFamily="49" charset="0"/>
                 <a:cs typeface="Consolas" panose="020B0609020204030204" pitchFamily="49" charset="0"/>
               </a:rPr>
-              <a:t>()</a:t>
-            </a:r>
-          </a:p>
-          <a:p>
-            <a:r>
-              <a:rPr lang="en-US" b="1" dirty="0">
-                <a:solidFill>
-                  <a:srgbClr val="00B050"/>
+              <a:t># 0</a:t>
+            </a:r>
+          </a:p>
+          <a:p>
+            <a:r>
+              <a:rPr lang="en-US" sz="1200" b="1" dirty="0" err="1">
+                <a:solidFill>
+                  <a:srgbClr val="0070C0"/>
                 </a:solidFill>
                 <a:latin typeface="Consolas" panose="020B0609020204030204" pitchFamily="49" charset="0"/>
                 <a:cs typeface="Consolas" panose="020B0609020204030204" pitchFamily="49" charset="0"/>
               </a:rPr>
-              <a:t># Perform a test that the probability of success is p.</a:t>
-            </a:r>
-          </a:p>
-          <a:p>
-            <a:r>
-              <a:rPr lang="en-US" b="1" dirty="0">
-                <a:solidFill>
-                  <a:srgbClr val="00B050"/>
+              <a:t>binom_test</a:t>
+            </a:r>
+            <a:r>
+              <a:rPr lang="en-US" sz="1200" b="1" dirty="0">
+                <a:solidFill>
+                  <a:srgbClr val="0070C0"/>
                 </a:solidFill>
                 <a:latin typeface="Consolas" panose="020B0609020204030204" pitchFamily="49" charset="0"/>
                 <a:cs typeface="Consolas" panose="020B0609020204030204" pitchFamily="49" charset="0"/>
               </a:rPr>
-              <a:t># Returns the p-value of the hypothesis test</a:t>
-            </a:r>
-          </a:p>
-          <a:p>
-            <a:endParaRPr lang="en-US" b="1" dirty="0">
-              <a:solidFill>
-                <a:srgbClr val="0070C0"/>
-              </a:solidFill>
-              <a:latin typeface="Consolas" panose="020B0609020204030204" pitchFamily="49" charset="0"/>
-              <a:cs typeface="Consolas" panose="020B0609020204030204" pitchFamily="49" charset="0"/>
-            </a:endParaRPr>
-          </a:p>
-          <a:p>
-            <a:r>
-              <a:rPr lang="en-US" b="1" dirty="0">
-                <a:solidFill>
-                  <a:srgbClr val="0070C0"/>
+              <a:t>(x=470, n=1000, p=1/2, alternative='less')  </a:t>
+            </a:r>
+            <a:r>
+              <a:rPr lang="en-US" sz="1200" b="1" dirty="0">
+                <a:solidFill>
+                  <a:srgbClr val="00B050"/>
                 </a:solidFill>
                 <a:latin typeface="Consolas" panose="020B0609020204030204" pitchFamily="49" charset="0"/>
                 <a:cs typeface="Consolas" panose="020B0609020204030204" pitchFamily="49" charset="0"/>
               </a:rPr>
-              <a:t>from </a:t>
-            </a:r>
-            <a:r>
-              <a:rPr lang="en-US" b="1" dirty="0" err="1">
+              <a:t># 0.031</a:t>
+            </a:r>
+          </a:p>
+          <a:p>
+            <a:r>
+              <a:rPr lang="en-US" sz="1200" b="1" dirty="0" err="1">
                 <a:solidFill>
                   <a:srgbClr val="0070C0"/>
                 </a:solidFill>
                 <a:latin typeface="Consolas" panose="020B0609020204030204" pitchFamily="49" charset="0"/>
                 <a:cs typeface="Consolas" panose="020B0609020204030204" pitchFamily="49" charset="0"/>
               </a:rPr>
-              <a:t>scipy.stats</a:t>
-            </a:r>
-            <a:r>
-              <a:rPr lang="en-US" b="1" dirty="0">
+              <a:t>binom_test</a:t>
+            </a:r>
+            <a:r>
+              <a:rPr lang="en-US" sz="1200" b="1" dirty="0">
                 <a:solidFill>
                   <a:srgbClr val="0070C0"/>
                 </a:solidFill>
                 <a:latin typeface="Consolas" panose="020B0609020204030204" pitchFamily="49" charset="0"/>
                 <a:cs typeface="Consolas" panose="020B0609020204030204" pitchFamily="49" charset="0"/>
               </a:rPr>
-              <a:t> import </a:t>
-            </a:r>
-            <a:r>
-              <a:rPr lang="en-US" b="1" dirty="0" err="1">
-                <a:solidFill>
-                  <a:srgbClr val="0070C0"/>
+              <a:t>(x=500, n=1000, p=1/2, alternative='less')  </a:t>
+            </a:r>
+            <a:r>
+              <a:rPr lang="en-US" sz="1200" b="1" dirty="0">
+                <a:solidFill>
+                  <a:srgbClr val="00B050"/>
                 </a:solidFill>
                 <a:latin typeface="Consolas" panose="020B0609020204030204" pitchFamily="49" charset="0"/>
                 <a:cs typeface="Consolas" panose="020B0609020204030204" pitchFamily="49" charset="0"/>
               </a:rPr>
-              <a:t>binom_test</a:t>
-            </a:r>
-            <a:endParaRPr lang="en-US" b="1" dirty="0">
-              <a:solidFill>
-                <a:srgbClr val="0070C0"/>
-              </a:solidFill>
-              <a:latin typeface="Consolas" panose="020B0609020204030204" pitchFamily="49" charset="0"/>
-              <a:cs typeface="Consolas" panose="020B0609020204030204" pitchFamily="49" charset="0"/>
-            </a:endParaRPr>
-          </a:p>
-          <a:p>
-            <a:endParaRPr lang="en-US" b="1" dirty="0">
-              <a:solidFill>
-                <a:srgbClr val="0070C0"/>
-              </a:solidFill>
-              <a:latin typeface="Consolas" panose="020B0609020204030204" pitchFamily="49" charset="0"/>
-              <a:cs typeface="Consolas" panose="020B0609020204030204" pitchFamily="49" charset="0"/>
-            </a:endParaRPr>
-          </a:p>
-          <a:p>
-            <a:r>
-              <a:rPr lang="en-US" b="1" dirty="0">
-                <a:solidFill>
-                  <a:srgbClr val="00B050"/>
+              <a:t># 0.5</a:t>
+            </a:r>
+          </a:p>
+          <a:p>
+            <a:r>
+              <a:rPr lang="en-US" sz="1200" b="1" dirty="0" err="1">
+                <a:solidFill>
+                  <a:srgbClr val="0070C0"/>
                 </a:solidFill>
                 <a:latin typeface="Consolas" panose="020B0609020204030204" pitchFamily="49" charset="0"/>
                 <a:cs typeface="Consolas" panose="020B0609020204030204" pitchFamily="49" charset="0"/>
               </a:rPr>
-              <a:t># Example: </a:t>
-            </a:r>
-          </a:p>
-          <a:p>
-            <a:r>
-              <a:rPr lang="en-US" b="1" dirty="0">
-                <a:solidFill>
-                  <a:srgbClr val="00B050"/>
+              <a:t>binom_test</a:t>
+            </a:r>
+            <a:r>
+              <a:rPr lang="en-US" sz="1200" b="1" dirty="0">
+                <a:solidFill>
+                  <a:srgbClr val="0070C0"/>
                 </a:solidFill>
                 <a:latin typeface="Consolas" panose="020B0609020204030204" pitchFamily="49" charset="0"/>
                 <a:cs typeface="Consolas" panose="020B0609020204030204" pitchFamily="49" charset="0"/>
               </a:rPr>
-              <a:t># We flip a coin 10 times and it lands on heads 8 times. </a:t>
-            </a:r>
-          </a:p>
-          <a:p>
-            <a:r>
-              <a:rPr lang="en-US" b="1" dirty="0">
+              <a:t>(x=530, n=1000, p=1/2, alternative='less')  </a:t>
+            </a:r>
+            <a:r>
+              <a:rPr lang="en-US" sz="1200" b="1" dirty="0">
                 <a:solidFill>
                   <a:srgbClr val="00B050"/>
                 </a:solidFill>
                 <a:latin typeface="Consolas" panose="020B0609020204030204" pitchFamily="49" charset="0"/>
                 <a:cs typeface="Consolas" panose="020B0609020204030204" pitchFamily="49" charset="0"/>
               </a:rPr>
-              <a:t># Perform a binomial test to determine if the coin is </a:t>
-            </a:r>
-          </a:p>
-          <a:p>
-            <a:r>
-              <a:rPr lang="en-US" b="1" dirty="0">
-                <a:solidFill>
-                  <a:srgbClr val="00B050"/>
+              <a:t># 0.973</a:t>
+            </a:r>
+          </a:p>
+          <a:p>
+            <a:r>
+              <a:rPr lang="en-US" sz="1200" b="1" dirty="0" err="1">
+                <a:solidFill>
+                  <a:srgbClr val="0070C0"/>
                 </a:solidFill>
                 <a:latin typeface="Consolas" panose="020B0609020204030204" pitchFamily="49" charset="0"/>
                 <a:cs typeface="Consolas" panose="020B0609020204030204" pitchFamily="49" charset="0"/>
               </a:rPr>
-              <a:t># biased towards heads.</a:t>
-            </a:r>
-          </a:p>
-          <a:p>
-            <a:r>
-              <a:rPr lang="en-US" b="1" dirty="0">
-                <a:solidFill>
-                  <a:srgbClr val="00B050"/>
+              <a:t>binom_test</a:t>
+            </a:r>
+            <a:r>
+              <a:rPr lang="en-US" sz="1200" b="1" dirty="0">
+                <a:solidFill>
+                  <a:srgbClr val="0070C0"/>
                 </a:solidFill>
                 <a:latin typeface="Consolas" panose="020B0609020204030204" pitchFamily="49" charset="0"/>
                 <a:cs typeface="Consolas" panose="020B0609020204030204" pitchFamily="49" charset="0"/>
               </a:rPr>
-              <a:t># </a:t>
-            </a:r>
-          </a:p>
-          <a:p>
-            <a:r>
-              <a:rPr lang="en-US" b="1" dirty="0">
+              <a:t>(x=999, n=1000, p=1/2, alternative='less')  </a:t>
+            </a:r>
+            <a:r>
+              <a:rPr lang="en-US" sz="1200" b="1" dirty="0">
                 <a:solidFill>
                   <a:srgbClr val="00B050"/>
                 </a:solidFill>
                 <a:latin typeface="Consolas" panose="020B0609020204030204" pitchFamily="49" charset="0"/>
                 <a:cs typeface="Consolas" panose="020B0609020204030204" pitchFamily="49" charset="0"/>
               </a:rPr>
-              <a:t># The null and alternative hypotheses:</a:t>
-            </a:r>
-          </a:p>
-          <a:p>
-            <a:r>
-              <a:rPr lang="en-US" b="1" dirty="0">
-                <a:solidFill>
-                  <a:srgbClr val="00B050"/>
-                </a:solidFill>
-                <a:latin typeface="Consolas" panose="020B0609020204030204" pitchFamily="49" charset="0"/>
-                <a:cs typeface="Consolas" panose="020B0609020204030204" pitchFamily="49" charset="0"/>
-              </a:rPr>
-              <a:t>#   H0: </a:t>
-            </a:r>
-            <a:r>
-              <a:rPr lang="el-GR" b="1" dirty="0">
-                <a:solidFill>
-                  <a:srgbClr val="00B050"/>
-                </a:solidFill>
-                <a:latin typeface="Consolas" panose="020B0609020204030204" pitchFamily="49" charset="0"/>
-                <a:cs typeface="Consolas" panose="020B0609020204030204" pitchFamily="49" charset="0"/>
-              </a:rPr>
-              <a:t>π ≤ 1/2 (</a:t>
-            </a:r>
-            <a:r>
-              <a:rPr lang="en-US" b="1" dirty="0">
-                <a:solidFill>
-                  <a:srgbClr val="00B050"/>
-                </a:solidFill>
-                <a:latin typeface="Consolas" panose="020B0609020204030204" pitchFamily="49" charset="0"/>
-                <a:cs typeface="Consolas" panose="020B0609020204030204" pitchFamily="49" charset="0"/>
-              </a:rPr>
-              <a:t>the coin is not biased towards heads)</a:t>
-            </a:r>
-          </a:p>
-          <a:p>
-            <a:r>
-              <a:rPr lang="en-US" b="1" dirty="0">
-                <a:solidFill>
-                  <a:srgbClr val="00B050"/>
-                </a:solidFill>
-                <a:latin typeface="Consolas" panose="020B0609020204030204" pitchFamily="49" charset="0"/>
-                <a:cs typeface="Consolas" panose="020B0609020204030204" pitchFamily="49" charset="0"/>
-              </a:rPr>
-              <a:t>#   HA: </a:t>
-            </a:r>
-            <a:r>
-              <a:rPr lang="el-GR" b="1" dirty="0">
-                <a:solidFill>
-                  <a:srgbClr val="00B050"/>
-                </a:solidFill>
-                <a:latin typeface="Consolas" panose="020B0609020204030204" pitchFamily="49" charset="0"/>
-                <a:cs typeface="Consolas" panose="020B0609020204030204" pitchFamily="49" charset="0"/>
-              </a:rPr>
-              <a:t>π &gt; 1/2</a:t>
-            </a:r>
-          </a:p>
-          <a:p>
-            <a:endParaRPr lang="el-GR" b="1" dirty="0">
-              <a:solidFill>
-                <a:srgbClr val="00B050"/>
-              </a:solidFill>
-              <a:latin typeface="Consolas" panose="020B0609020204030204" pitchFamily="49" charset="0"/>
-              <a:cs typeface="Consolas" panose="020B0609020204030204" pitchFamily="49" charset="0"/>
-            </a:endParaRPr>
-          </a:p>
-          <a:p>
-            <a:r>
-              <a:rPr lang="en-US" b="1" dirty="0" err="1">
-                <a:solidFill>
-                  <a:srgbClr val="0070C0"/>
-                </a:solidFill>
-                <a:latin typeface="Consolas" panose="020B0609020204030204" pitchFamily="49" charset="0"/>
-                <a:cs typeface="Consolas" panose="020B0609020204030204" pitchFamily="49" charset="0"/>
-              </a:rPr>
-              <a:t>binom_test</a:t>
-            </a:r>
-            <a:r>
-              <a:rPr lang="en-US" b="1" dirty="0">
-                <a:solidFill>
-                  <a:srgbClr val="0070C0"/>
-                </a:solidFill>
-                <a:latin typeface="Consolas" panose="020B0609020204030204" pitchFamily="49" charset="0"/>
-                <a:cs typeface="Consolas" panose="020B0609020204030204" pitchFamily="49" charset="0"/>
-              </a:rPr>
-              <a:t>(x=8, n=10, p=1/2, alternative='greater')</a:t>
-            </a:r>
-          </a:p>
-          <a:p>
-            <a:endParaRPr lang="en-US" b="1" dirty="0">
-              <a:solidFill>
-                <a:srgbClr val="00B050"/>
-              </a:solidFill>
-              <a:latin typeface="Consolas" panose="020B0609020204030204" pitchFamily="49" charset="0"/>
-              <a:cs typeface="Consolas" panose="020B0609020204030204" pitchFamily="49" charset="0"/>
-            </a:endParaRPr>
-          </a:p>
-          <a:p>
-            <a:r>
-              <a:rPr lang="en-US" b="1" dirty="0">
-                <a:solidFill>
-                  <a:srgbClr val="00B050"/>
-                </a:solidFill>
-                <a:latin typeface="Consolas" panose="020B0609020204030204" pitchFamily="49" charset="0"/>
-                <a:cs typeface="Consolas" panose="020B0609020204030204" pitchFamily="49" charset="0"/>
-              </a:rPr>
-              <a:t># P = 0.0546875</a:t>
-            </a:r>
-          </a:p>
-          <a:p>
-            <a:endParaRPr lang="en-US" b="1" dirty="0">
-              <a:solidFill>
-                <a:srgbClr val="00B050"/>
-              </a:solidFill>
-              <a:latin typeface="Consolas" panose="020B0609020204030204" pitchFamily="49" charset="0"/>
-              <a:cs typeface="Consolas" panose="020B0609020204030204" pitchFamily="49" charset="0"/>
-            </a:endParaRPr>
-          </a:p>
-          <a:p>
-            <a:r>
-              <a:rPr lang="en-US" b="1" dirty="0">
-                <a:solidFill>
-                  <a:srgbClr val="00B050"/>
-                </a:solidFill>
-                <a:latin typeface="Consolas" panose="020B0609020204030204" pitchFamily="49" charset="0"/>
-                <a:cs typeface="Consolas" panose="020B0609020204030204" pitchFamily="49" charset="0"/>
-              </a:rPr>
-              <a:t># Because this p-value (0.0546875) is not less than 0.05, </a:t>
-            </a:r>
-          </a:p>
-          <a:p>
-            <a:r>
-              <a:rPr lang="en-US" b="1" dirty="0">
-                <a:solidFill>
-                  <a:srgbClr val="00B050"/>
-                </a:solidFill>
-                <a:latin typeface="Consolas" panose="020B0609020204030204" pitchFamily="49" charset="0"/>
-                <a:cs typeface="Consolas" panose="020B0609020204030204" pitchFamily="49" charset="0"/>
-              </a:rPr>
-              <a:t># we fail to reject the null hypothesis. </a:t>
-            </a:r>
-          </a:p>
-          <a:p>
-            <a:r>
-              <a:rPr lang="en-US" b="1" dirty="0">
-                <a:solidFill>
-                  <a:srgbClr val="00B050"/>
-                </a:solidFill>
-                <a:latin typeface="Consolas" panose="020B0609020204030204" pitchFamily="49" charset="0"/>
-                <a:cs typeface="Consolas" panose="020B0609020204030204" pitchFamily="49" charset="0"/>
-              </a:rPr>
-              <a:t># We do not have sufficient evidence to say </a:t>
-            </a:r>
-          </a:p>
-          <a:p>
-            <a:r>
-              <a:rPr lang="en-US" b="1" dirty="0">
-                <a:solidFill>
-                  <a:srgbClr val="00B050"/>
-                </a:solidFill>
-                <a:latin typeface="Consolas" panose="020B0609020204030204" pitchFamily="49" charset="0"/>
-                <a:cs typeface="Consolas" panose="020B0609020204030204" pitchFamily="49" charset="0"/>
-              </a:rPr>
-              <a:t># that the coin is biased towards heads.</a:t>
+              <a:t># 1</a:t>
             </a:r>
           </a:p>
         </p:txBody>
@@ -17975,8 +17778,8 @@
         </p:nvSpPr>
         <p:spPr>
           <a:xfrm>
-            <a:off x="136478" y="870276"/>
-            <a:ext cx="4148919" cy="3970318"/>
+            <a:off x="55090" y="507831"/>
+            <a:ext cx="3871452" cy="1384995"/>
           </a:xfrm>
           <a:prstGeom prst="rect">
             <a:avLst/>
@@ -17999,65 +17802,6 @@
               </a:rPr>
               <a:t># binomial distribution</a:t>
             </a:r>
-            <a:endParaRPr lang="en-US" dirty="0">
-              <a:solidFill>
-                <a:srgbClr val="0070C0"/>
-              </a:solidFill>
-              <a:latin typeface="Consolas" panose="020B0609020204030204" pitchFamily="49" charset="0"/>
-              <a:cs typeface="Consolas" panose="020B0609020204030204" pitchFamily="49" charset="0"/>
-            </a:endParaRPr>
-          </a:p>
-          <a:p>
-            <a:r>
-              <a:rPr lang="en-US" dirty="0">
-                <a:solidFill>
-                  <a:srgbClr val="0070C0"/>
-                </a:solidFill>
-                <a:latin typeface="Consolas" panose="020B0609020204030204" pitchFamily="49" charset="0"/>
-                <a:cs typeface="Consolas" panose="020B0609020204030204" pitchFamily="49" charset="0"/>
-              </a:rPr>
-              <a:t>from </a:t>
-            </a:r>
-            <a:r>
-              <a:rPr lang="en-US" dirty="0" err="1">
-                <a:solidFill>
-                  <a:srgbClr val="0070C0"/>
-                </a:solidFill>
-                <a:latin typeface="Consolas" panose="020B0609020204030204" pitchFamily="49" charset="0"/>
-                <a:cs typeface="Consolas" panose="020B0609020204030204" pitchFamily="49" charset="0"/>
-              </a:rPr>
-              <a:t>scipy.stats</a:t>
-            </a:r>
-            <a:r>
-              <a:rPr lang="en-US" dirty="0">
-                <a:solidFill>
-                  <a:srgbClr val="0070C0"/>
-                </a:solidFill>
-                <a:latin typeface="Consolas" panose="020B0609020204030204" pitchFamily="49" charset="0"/>
-                <a:cs typeface="Consolas" panose="020B0609020204030204" pitchFamily="49" charset="0"/>
-              </a:rPr>
-              <a:t> import </a:t>
-            </a:r>
-            <a:r>
-              <a:rPr lang="en-US" dirty="0" err="1">
-                <a:solidFill>
-                  <a:srgbClr val="0070C0"/>
-                </a:solidFill>
-                <a:latin typeface="Consolas" panose="020B0609020204030204" pitchFamily="49" charset="0"/>
-                <a:cs typeface="Consolas" panose="020B0609020204030204" pitchFamily="49" charset="0"/>
-              </a:rPr>
-              <a:t>binom</a:t>
-            </a:r>
-            <a:r>
-              <a:rPr lang="en-US" dirty="0">
-                <a:solidFill>
-                  <a:srgbClr val="0070C0"/>
-                </a:solidFill>
-                <a:latin typeface="Consolas" panose="020B0609020204030204" pitchFamily="49" charset="0"/>
-                <a:cs typeface="Consolas" panose="020B0609020204030204" pitchFamily="49" charset="0"/>
-              </a:rPr>
-              <a:t> </a:t>
-            </a:r>
           </a:p>
           <a:p>
             <a:endParaRPr lang="en-US" b="1" dirty="0">
@@ -18070,101 +17814,45 @@
           </a:p>
           <a:p>
             <a:r>
-              <a:rPr lang="en-US" dirty="0" err="1">
-                <a:solidFill>
-                  <a:srgbClr val="0070C0"/>
+              <a:rPr lang="en-US" b="1" dirty="0" err="1">
+                <a:solidFill>
+                  <a:srgbClr val="FF0000"/>
                 </a:solidFill>
                 <a:latin typeface="Consolas" panose="020B0609020204030204" pitchFamily="49" charset="0"/>
                 <a:cs typeface="Consolas" panose="020B0609020204030204" pitchFamily="49" charset="0"/>
               </a:rPr>
-              <a:t>binom.pmf</a:t>
+              <a:t>pmf</a:t>
             </a:r>
             <a:r>
               <a:rPr lang="en-US" dirty="0">
                 <a:solidFill>
-                  <a:srgbClr val="0070C0"/>
+                  <a:schemeClr val="tx1"/>
                 </a:solidFill>
                 <a:latin typeface="Consolas" panose="020B0609020204030204" pitchFamily="49" charset="0"/>
                 <a:cs typeface="Consolas" panose="020B0609020204030204" pitchFamily="49" charset="0"/>
               </a:rPr>
-              <a:t>(0,2,0.5) </a:t>
+              <a:t> = </a:t>
             </a:r>
             <a:r>
               <a:rPr lang="en-US" b="1" dirty="0">
                 <a:solidFill>
-                  <a:srgbClr val="00B050"/>
+                  <a:srgbClr val="0070C0"/>
                 </a:solidFill>
                 <a:latin typeface="Consolas" panose="020B0609020204030204" pitchFamily="49" charset="0"/>
                 <a:cs typeface="Consolas" panose="020B0609020204030204" pitchFamily="49" charset="0"/>
               </a:rPr>
-              <a:t># 0.25</a:t>
-            </a:r>
-          </a:p>
-          <a:p>
-            <a:r>
-              <a:rPr lang="en-US" dirty="0" err="1">
-                <a:solidFill>
-                  <a:srgbClr val="0070C0"/>
+              <a:t>probability mass function </a:t>
+            </a:r>
+            <a:r>
+              <a:rPr lang="en-US" dirty="0">
+                <a:solidFill>
+                  <a:schemeClr val="tx1"/>
                 </a:solidFill>
                 <a:latin typeface="Consolas" panose="020B0609020204030204" pitchFamily="49" charset="0"/>
                 <a:cs typeface="Consolas" panose="020B0609020204030204" pitchFamily="49" charset="0"/>
               </a:rPr>
-              <a:t>binom.pmf</a:t>
-            </a:r>
-            <a:r>
-              <a:rPr lang="en-US" dirty="0">
-                <a:solidFill>
-                  <a:srgbClr val="0070C0"/>
-                </a:solidFill>
-                <a:latin typeface="Consolas" panose="020B0609020204030204" pitchFamily="49" charset="0"/>
-                <a:cs typeface="Consolas" panose="020B0609020204030204" pitchFamily="49" charset="0"/>
-              </a:rPr>
-              <a:t>(1,2,0.5) </a:t>
-            </a:r>
-            <a:r>
-              <a:rPr lang="en-US" b="1" dirty="0">
-                <a:solidFill>
-                  <a:srgbClr val="00B050"/>
-                </a:solidFill>
-                <a:latin typeface="Consolas" panose="020B0609020204030204" pitchFamily="49" charset="0"/>
-                <a:cs typeface="Consolas" panose="020B0609020204030204" pitchFamily="49" charset="0"/>
-              </a:rPr>
-              <a:t># 0.5</a:t>
-            </a:r>
-          </a:p>
-          <a:p>
-            <a:r>
-              <a:rPr lang="en-US" dirty="0" err="1">
-                <a:solidFill>
-                  <a:srgbClr val="0070C0"/>
-                </a:solidFill>
-                <a:latin typeface="Consolas" panose="020B0609020204030204" pitchFamily="49" charset="0"/>
-                <a:cs typeface="Consolas" panose="020B0609020204030204" pitchFamily="49" charset="0"/>
-              </a:rPr>
-              <a:t>binom.pmf</a:t>
-            </a:r>
-            <a:r>
-              <a:rPr lang="en-US" dirty="0">
-                <a:solidFill>
-                  <a:srgbClr val="0070C0"/>
-                </a:solidFill>
-                <a:latin typeface="Consolas" panose="020B0609020204030204" pitchFamily="49" charset="0"/>
-                <a:cs typeface="Consolas" panose="020B0609020204030204" pitchFamily="49" charset="0"/>
-              </a:rPr>
-              <a:t>(2,2,0.5) </a:t>
-            </a:r>
-            <a:r>
-              <a:rPr lang="en-US" b="1" dirty="0">
-                <a:solidFill>
-                  <a:srgbClr val="00B050"/>
-                </a:solidFill>
-                <a:latin typeface="Consolas" panose="020B0609020204030204" pitchFamily="49" charset="0"/>
-                <a:cs typeface="Consolas" panose="020B0609020204030204" pitchFamily="49" charset="0"/>
-              </a:rPr>
-              <a:t># 0.25</a:t>
-            </a:r>
-          </a:p>
-          <a:p>
+              <a:t>- gives the probability that a discrete random variable is exactly equal to some value</a:t>
+            </a:r>
             <a:endParaRPr lang="en-US" b="1" dirty="0">
               <a:solidFill>
                 <a:srgbClr val="00B050"/>
@@ -18172,265 +17860,6 @@
               <a:latin typeface="Consolas" panose="020B0609020204030204" pitchFamily="49" charset="0"/>
               <a:cs typeface="Consolas" panose="020B0609020204030204" pitchFamily="49" charset="0"/>
             </a:endParaRPr>
-          </a:p>
-          <a:p>
-            <a:r>
-              <a:rPr lang="en-US" dirty="0">
-                <a:solidFill>
-                  <a:srgbClr val="0070C0"/>
-                </a:solidFill>
-                <a:latin typeface="Consolas" panose="020B0609020204030204" pitchFamily="49" charset="0"/>
-                <a:cs typeface="Consolas" panose="020B0609020204030204" pitchFamily="49" charset="0"/>
-              </a:rPr>
-              <a:t>n=10</a:t>
-            </a:r>
-          </a:p>
-          <a:p>
-            <a:r>
-              <a:rPr lang="en-US" dirty="0" err="1">
-                <a:solidFill>
-                  <a:srgbClr val="0070C0"/>
-                </a:solidFill>
-                <a:latin typeface="Consolas" panose="020B0609020204030204" pitchFamily="49" charset="0"/>
-                <a:cs typeface="Consolas" panose="020B0609020204030204" pitchFamily="49" charset="0"/>
-              </a:rPr>
-              <a:t>arr</a:t>
-            </a:r>
-            <a:r>
-              <a:rPr lang="en-US" dirty="0">
-                <a:solidFill>
-                  <a:srgbClr val="0070C0"/>
-                </a:solidFill>
-                <a:latin typeface="Consolas" panose="020B0609020204030204" pitchFamily="49" charset="0"/>
-                <a:cs typeface="Consolas" panose="020B0609020204030204" pitchFamily="49" charset="0"/>
-              </a:rPr>
-              <a:t> = []</a:t>
-            </a:r>
-          </a:p>
-          <a:p>
-            <a:r>
-              <a:rPr lang="en-US" dirty="0">
-                <a:solidFill>
-                  <a:srgbClr val="0070C0"/>
-                </a:solidFill>
-                <a:latin typeface="Consolas" panose="020B0609020204030204" pitchFamily="49" charset="0"/>
-                <a:cs typeface="Consolas" panose="020B0609020204030204" pitchFamily="49" charset="0"/>
-              </a:rPr>
-              <a:t>for ii in range(n+1):</a:t>
-            </a:r>
-          </a:p>
-          <a:p>
-            <a:r>
-              <a:rPr lang="en-US" dirty="0">
-                <a:solidFill>
-                  <a:srgbClr val="0070C0"/>
-                </a:solidFill>
-                <a:latin typeface="Consolas" panose="020B0609020204030204" pitchFamily="49" charset="0"/>
-                <a:cs typeface="Consolas" panose="020B0609020204030204" pitchFamily="49" charset="0"/>
-              </a:rPr>
-              <a:t>    </a:t>
-            </a:r>
-            <a:r>
-              <a:rPr lang="en-US" dirty="0" err="1">
-                <a:solidFill>
-                  <a:srgbClr val="0070C0"/>
-                </a:solidFill>
-                <a:latin typeface="Consolas" panose="020B0609020204030204" pitchFamily="49" charset="0"/>
-                <a:cs typeface="Consolas" panose="020B0609020204030204" pitchFamily="49" charset="0"/>
-              </a:rPr>
-              <a:t>arr.append</a:t>
-            </a:r>
-            <a:r>
-              <a:rPr lang="en-US" dirty="0">
-                <a:solidFill>
-                  <a:srgbClr val="0070C0"/>
-                </a:solidFill>
-                <a:latin typeface="Consolas" panose="020B0609020204030204" pitchFamily="49" charset="0"/>
-                <a:cs typeface="Consolas" panose="020B0609020204030204" pitchFamily="49" charset="0"/>
-              </a:rPr>
-              <a:t>(</a:t>
-            </a:r>
-            <a:r>
-              <a:rPr lang="en-US" dirty="0" err="1">
-                <a:solidFill>
-                  <a:srgbClr val="0070C0"/>
-                </a:solidFill>
-                <a:latin typeface="Consolas" panose="020B0609020204030204" pitchFamily="49" charset="0"/>
-                <a:cs typeface="Consolas" panose="020B0609020204030204" pitchFamily="49" charset="0"/>
-              </a:rPr>
-              <a:t>binom.pmf</a:t>
-            </a:r>
-            <a:r>
-              <a:rPr lang="en-US" dirty="0">
-                <a:solidFill>
-                  <a:srgbClr val="0070C0"/>
-                </a:solidFill>
-                <a:latin typeface="Consolas" panose="020B0609020204030204" pitchFamily="49" charset="0"/>
-                <a:cs typeface="Consolas" panose="020B0609020204030204" pitchFamily="49" charset="0"/>
-              </a:rPr>
-              <a:t>(ii, n, 0.5))</a:t>
-            </a:r>
-          </a:p>
-          <a:p>
-            <a:r>
-              <a:rPr lang="en-US" dirty="0">
-                <a:solidFill>
-                  <a:srgbClr val="0070C0"/>
-                </a:solidFill>
-                <a:latin typeface="Consolas" panose="020B0609020204030204" pitchFamily="49" charset="0"/>
-                <a:cs typeface="Consolas" panose="020B0609020204030204" pitchFamily="49" charset="0"/>
-              </a:rPr>
-              <a:t>print(sum(</a:t>
-            </a:r>
-            <a:r>
-              <a:rPr lang="en-US" dirty="0" err="1">
-                <a:solidFill>
-                  <a:srgbClr val="0070C0"/>
-                </a:solidFill>
-                <a:latin typeface="Consolas" panose="020B0609020204030204" pitchFamily="49" charset="0"/>
-                <a:cs typeface="Consolas" panose="020B0609020204030204" pitchFamily="49" charset="0"/>
-              </a:rPr>
-              <a:t>arr</a:t>
-            </a:r>
-            <a:r>
-              <a:rPr lang="en-US" dirty="0">
-                <a:solidFill>
-                  <a:srgbClr val="0070C0"/>
-                </a:solidFill>
-                <a:latin typeface="Consolas" panose="020B0609020204030204" pitchFamily="49" charset="0"/>
-                <a:cs typeface="Consolas" panose="020B0609020204030204" pitchFamily="49" charset="0"/>
-              </a:rPr>
-              <a:t>))</a:t>
-            </a:r>
-            <a:r>
-              <a:rPr lang="en-US" b="1" dirty="0">
-                <a:solidFill>
-                  <a:srgbClr val="00B050"/>
-                </a:solidFill>
-                <a:latin typeface="Consolas" panose="020B0609020204030204" pitchFamily="49" charset="0"/>
-                <a:cs typeface="Consolas" panose="020B0609020204030204" pitchFamily="49" charset="0"/>
-              </a:rPr>
-              <a:t>  # 1</a:t>
-            </a:r>
-          </a:p>
-          <a:p>
-            <a:r>
-              <a:rPr lang="en-US" dirty="0">
-                <a:solidFill>
-                  <a:srgbClr val="0070C0"/>
-                </a:solidFill>
-                <a:latin typeface="Consolas" panose="020B0609020204030204" pitchFamily="49" charset="0"/>
-                <a:cs typeface="Consolas" panose="020B0609020204030204" pitchFamily="49" charset="0"/>
-              </a:rPr>
-              <a:t>print(</a:t>
-            </a:r>
-            <a:r>
-              <a:rPr lang="en-US" dirty="0" err="1">
-                <a:solidFill>
-                  <a:srgbClr val="0070C0"/>
-                </a:solidFill>
-                <a:latin typeface="Consolas" panose="020B0609020204030204" pitchFamily="49" charset="0"/>
-                <a:cs typeface="Consolas" panose="020B0609020204030204" pitchFamily="49" charset="0"/>
-              </a:rPr>
-              <a:t>arr</a:t>
-            </a:r>
-            <a:r>
-              <a:rPr lang="en-US" dirty="0">
-                <a:solidFill>
-                  <a:srgbClr val="0070C0"/>
-                </a:solidFill>
-                <a:latin typeface="Consolas" panose="020B0609020204030204" pitchFamily="49" charset="0"/>
-                <a:cs typeface="Consolas" panose="020B0609020204030204" pitchFamily="49" charset="0"/>
-              </a:rPr>
-              <a:t>)</a:t>
-            </a:r>
-          </a:p>
-          <a:p>
-            <a:endParaRPr lang="en-US" b="1" dirty="0">
-              <a:solidFill>
-                <a:srgbClr val="00B050"/>
-              </a:solidFill>
-              <a:latin typeface="Consolas" panose="020B0609020204030204" pitchFamily="49" charset="0"/>
-              <a:cs typeface="Consolas" panose="020B0609020204030204" pitchFamily="49" charset="0"/>
-            </a:endParaRPr>
-          </a:p>
-          <a:p>
-            <a:r>
-              <a:rPr lang="en-US" b="1" dirty="0">
-                <a:solidFill>
-                  <a:srgbClr val="00B050"/>
-                </a:solidFill>
-                <a:latin typeface="Consolas" panose="020B0609020204030204" pitchFamily="49" charset="0"/>
-                <a:cs typeface="Consolas" panose="020B0609020204030204" pitchFamily="49" charset="0"/>
-              </a:rPr>
-              <a:t># 8, 9, 10 heads out of 10 trials:</a:t>
-            </a:r>
-          </a:p>
-          <a:p>
-            <a:r>
-              <a:rPr lang="en-US" dirty="0" err="1">
-                <a:solidFill>
-                  <a:srgbClr val="0070C0"/>
-                </a:solidFill>
-                <a:latin typeface="Consolas" panose="020B0609020204030204" pitchFamily="49" charset="0"/>
-                <a:cs typeface="Consolas" panose="020B0609020204030204" pitchFamily="49" charset="0"/>
-              </a:rPr>
-              <a:t>binom.pmf</a:t>
-            </a:r>
-            <a:r>
-              <a:rPr lang="en-US" dirty="0">
-                <a:solidFill>
-                  <a:srgbClr val="0070C0"/>
-                </a:solidFill>
-                <a:latin typeface="Consolas" panose="020B0609020204030204" pitchFamily="49" charset="0"/>
-                <a:cs typeface="Consolas" panose="020B0609020204030204" pitchFamily="49" charset="0"/>
-              </a:rPr>
-              <a:t>(8,10,0.5)  # 0.043945</a:t>
-            </a:r>
-          </a:p>
-          <a:p>
-            <a:r>
-              <a:rPr lang="en-US" dirty="0" err="1">
-                <a:solidFill>
-                  <a:srgbClr val="0070C0"/>
-                </a:solidFill>
-                <a:latin typeface="Consolas" panose="020B0609020204030204" pitchFamily="49" charset="0"/>
-                <a:cs typeface="Consolas" panose="020B0609020204030204" pitchFamily="49" charset="0"/>
-              </a:rPr>
-              <a:t>binom.pmf</a:t>
-            </a:r>
-            <a:r>
-              <a:rPr lang="en-US" dirty="0">
-                <a:solidFill>
-                  <a:srgbClr val="0070C0"/>
-                </a:solidFill>
-                <a:latin typeface="Consolas" panose="020B0609020204030204" pitchFamily="49" charset="0"/>
-                <a:cs typeface="Consolas" panose="020B0609020204030204" pitchFamily="49" charset="0"/>
-              </a:rPr>
-              <a:t>(9,10,0.5)  # 0.009766</a:t>
-            </a:r>
-          </a:p>
-          <a:p>
-            <a:r>
-              <a:rPr lang="en-US" dirty="0" err="1">
-                <a:solidFill>
-                  <a:srgbClr val="0070C0"/>
-                </a:solidFill>
-                <a:latin typeface="Consolas" panose="020B0609020204030204" pitchFamily="49" charset="0"/>
-                <a:cs typeface="Consolas" panose="020B0609020204030204" pitchFamily="49" charset="0"/>
-              </a:rPr>
-              <a:t>binom.pmf</a:t>
-            </a:r>
-            <a:r>
-              <a:rPr lang="en-US" dirty="0">
-                <a:solidFill>
-                  <a:srgbClr val="0070C0"/>
-                </a:solidFill>
-                <a:latin typeface="Consolas" panose="020B0609020204030204" pitchFamily="49" charset="0"/>
-                <a:cs typeface="Consolas" panose="020B0609020204030204" pitchFamily="49" charset="0"/>
-              </a:rPr>
-              <a:t>(10,10,0.5) # 0.000977</a:t>
-            </a:r>
           </a:p>
         </p:txBody>
       </p:sp>
@@ -18462,7 +17891,7 @@
         </p:blipFill>
         <p:spPr>
           <a:xfrm>
-            <a:off x="8990463" y="778334"/>
+            <a:off x="1564141" y="1752488"/>
             <a:ext cx="2260600" cy="647700"/>
           </a:xfrm>
           <a:prstGeom prst="rect">
@@ -18470,82 +17899,6 @@
           </a:prstGeom>
         </p:spPr>
       </p:pic>
-      <p:sp>
-        <p:nvSpPr>
-          <p:cNvPr id="10" name="TextBox 9">
-            <a:extLst>
-              <a:ext uri="{FF2B5EF4-FFF2-40B4-BE49-F238E27FC236}">
-                <a16:creationId xmlns:a16="http://schemas.microsoft.com/office/drawing/2014/main" id="{6C439360-5990-7549-AAFB-E0168AA36860}"/>
-              </a:ext>
-            </a:extLst>
-          </p:cNvPr>
-          <p:cNvSpPr txBox="1"/>
-          <p:nvPr/>
-        </p:nvSpPr>
-        <p:spPr>
-          <a:xfrm>
-            <a:off x="5882186" y="246221"/>
-            <a:ext cx="6216554" cy="523220"/>
-          </a:xfrm>
-          <a:prstGeom prst="rect">
-            <a:avLst/>
-          </a:prstGeom>
-          <a:noFill/>
-        </p:spPr>
-        <p:txBody>
-          <a:bodyPr wrap="square" rtlCol="0">
-            <a:spAutoFit/>
-          </a:bodyPr>
-          <a:lstStyle/>
-          <a:p>
-            <a:r>
-              <a:rPr lang="en-US" b="1" dirty="0" err="1">
-                <a:solidFill>
-                  <a:srgbClr val="FF0000"/>
-                </a:solidFill>
-                <a:latin typeface="Consolas" panose="020B0609020204030204" pitchFamily="49" charset="0"/>
-                <a:cs typeface="Consolas" panose="020B0609020204030204" pitchFamily="49" charset="0"/>
-              </a:rPr>
-              <a:t>pmf</a:t>
-            </a:r>
-            <a:r>
-              <a:rPr lang="en-US" dirty="0">
-                <a:solidFill>
-                  <a:schemeClr val="tx1"/>
-                </a:solidFill>
-                <a:latin typeface="Consolas" panose="020B0609020204030204" pitchFamily="49" charset="0"/>
-                <a:cs typeface="Consolas" panose="020B0609020204030204" pitchFamily="49" charset="0"/>
-              </a:rPr>
-              <a:t> = </a:t>
-            </a:r>
-            <a:r>
-              <a:rPr lang="en-US" b="1" dirty="0">
-                <a:solidFill>
-                  <a:srgbClr val="0070C0"/>
-                </a:solidFill>
-                <a:latin typeface="Consolas" panose="020B0609020204030204" pitchFamily="49" charset="0"/>
-                <a:cs typeface="Consolas" panose="020B0609020204030204" pitchFamily="49" charset="0"/>
-              </a:rPr>
-              <a:t>probability mass function </a:t>
-            </a:r>
-            <a:r>
-              <a:rPr lang="en-US" dirty="0">
-                <a:solidFill>
-                  <a:schemeClr val="tx1"/>
-                </a:solidFill>
-                <a:latin typeface="Consolas" panose="020B0609020204030204" pitchFamily="49" charset="0"/>
-                <a:cs typeface="Consolas" panose="020B0609020204030204" pitchFamily="49" charset="0"/>
-              </a:rPr>
-              <a:t>- gives the probability that a discrete random variable is exactly equal to some value</a:t>
-            </a:r>
-            <a:endParaRPr lang="en-US" dirty="0">
-              <a:solidFill>
-                <a:schemeClr val="tx1"/>
-              </a:solidFill>
-            </a:endParaRPr>
-          </a:p>
-        </p:txBody>
-      </p:sp>
       <p:sp>
         <p:nvSpPr>
           <p:cNvPr id="11" name="TextBox 10">
@@ -18560,8 +17913,8 @@
         </p:nvSpPr>
         <p:spPr>
           <a:xfrm>
-            <a:off x="6271146" y="948295"/>
-            <a:ext cx="1323833" cy="307777"/>
+            <a:off x="0" y="1940107"/>
+            <a:ext cx="1462340" cy="307777"/>
           </a:xfrm>
           <a:prstGeom prst="rect">
             <a:avLst/>
@@ -18576,54 +17929,1288 @@
           <a:p>
             <a:r>
               <a:rPr lang="en-US" dirty="0"/>
-              <a:t>Binomial PMF</a:t>
+              <a:t>Binomial PMF :</a:t>
             </a:r>
           </a:p>
         </p:txBody>
       </p:sp>
-      <p:sp>
-        <p:nvSpPr>
-          <p:cNvPr id="12" name="Right Arrow 11">
+      <p:pic>
+        <p:nvPicPr>
+          <p:cNvPr id="3" name="Picture 2">
             <a:extLst>
               <a:ext uri="{FF2B5EF4-FFF2-40B4-BE49-F238E27FC236}">
-                <a16:creationId xmlns:a16="http://schemas.microsoft.com/office/drawing/2014/main" id="{B2B661F4-C902-DE4E-84B8-651079ECB2CC}"/>
+                <a16:creationId xmlns:a16="http://schemas.microsoft.com/office/drawing/2014/main" id="{8A7A16D1-6A82-EE42-84CE-7A1B0E0722C6}"/>
               </a:ext>
             </a:extLst>
           </p:cNvPr>
-          <p:cNvSpPr/>
+          <p:cNvPicPr>
+            <a:picLocks noChangeAspect="1"/>
+          </p:cNvPicPr>
+          <p:nvPr/>
+        </p:nvPicPr>
+        <p:blipFill>
+          <a:blip r:embed="rId3" cstate="email">
+            <a:extLst>
+              <a:ext uri="{28A0092B-C50C-407E-A947-70E740481C1C}">
+                <a14:useLocalDpi xmlns:a14="http://schemas.microsoft.com/office/drawing/2010/main"/>
+              </a:ext>
+            </a:extLst>
+          </a:blip>
+          <a:stretch>
+            <a:fillRect/>
+          </a:stretch>
+        </p:blipFill>
+        <p:spPr>
+          <a:xfrm>
+            <a:off x="4107674" y="2786705"/>
+            <a:ext cx="1955444" cy="1303629"/>
+          </a:xfrm>
+          <a:prstGeom prst="rect">
+            <a:avLst/>
+          </a:prstGeom>
+        </p:spPr>
+      </p:pic>
+      <p:sp>
+        <p:nvSpPr>
+          <p:cNvPr id="13" name="TextBox 12">
+            <a:extLst>
+              <a:ext uri="{FF2B5EF4-FFF2-40B4-BE49-F238E27FC236}">
+                <a16:creationId xmlns:a16="http://schemas.microsoft.com/office/drawing/2014/main" id="{7A8963DC-8A72-D44C-ABD9-A5F73EA7B869}"/>
+              </a:ext>
+            </a:extLst>
+          </p:cNvPr>
+          <p:cNvSpPr txBox="1"/>
           <p:nvPr/>
         </p:nvSpPr>
         <p:spPr>
           <a:xfrm>
-            <a:off x="7944703" y="1047990"/>
-            <a:ext cx="696035" cy="187769"/>
+            <a:off x="4082134" y="5491884"/>
+            <a:ext cx="5884256" cy="1015663"/>
           </a:xfrm>
-          <a:prstGeom prst="rightArrow">
+          <a:prstGeom prst="rect">
             <a:avLst/>
           </a:prstGeom>
+          <a:noFill/>
+        </p:spPr>
+        <p:txBody>
+          <a:bodyPr wrap="square" rtlCol="0">
+            <a:spAutoFit/>
+          </a:bodyPr>
+          <a:lstStyle/>
+          <a:p>
+            <a:r>
+              <a:rPr lang="en-US" sz="1200" b="1" dirty="0">
+                <a:solidFill>
+                  <a:srgbClr val="00B050"/>
+                </a:solidFill>
+                <a:latin typeface="Consolas" panose="020B0609020204030204" pitchFamily="49" charset="0"/>
+                <a:cs typeface="Consolas" panose="020B0609020204030204" pitchFamily="49" charset="0"/>
+              </a:rPr>
+              <a:t># We flip a coin 10 times and it lands on heads 8 times. </a:t>
+            </a:r>
+          </a:p>
+          <a:p>
+            <a:r>
+              <a:rPr lang="en-US" sz="1200" b="1" dirty="0">
+                <a:solidFill>
+                  <a:srgbClr val="00B050"/>
+                </a:solidFill>
+                <a:latin typeface="Consolas" panose="020B0609020204030204" pitchFamily="49" charset="0"/>
+                <a:cs typeface="Consolas" panose="020B0609020204030204" pitchFamily="49" charset="0"/>
+              </a:rPr>
+              <a:t># Perform a binomial test to determine if the coin is biased.</a:t>
+            </a:r>
+          </a:p>
+          <a:p>
+            <a:r>
+              <a:rPr lang="en-US" sz="1200" b="1" dirty="0" err="1">
+                <a:solidFill>
+                  <a:srgbClr val="0070C0"/>
+                </a:solidFill>
+                <a:latin typeface="Consolas" panose="020B0609020204030204" pitchFamily="49" charset="0"/>
+                <a:cs typeface="Consolas" panose="020B0609020204030204" pitchFamily="49" charset="0"/>
+              </a:rPr>
+              <a:t>binom_test</a:t>
+            </a:r>
+            <a:r>
+              <a:rPr lang="en-US" sz="1200" b="1" dirty="0">
+                <a:solidFill>
+                  <a:srgbClr val="0070C0"/>
+                </a:solidFill>
+                <a:latin typeface="Consolas" panose="020B0609020204030204" pitchFamily="49" charset="0"/>
+                <a:cs typeface="Consolas" panose="020B0609020204030204" pitchFamily="49" charset="0"/>
+              </a:rPr>
+              <a:t>(x=8, n=10, p=1/2, alternative='greater') </a:t>
+            </a:r>
+            <a:r>
+              <a:rPr lang="en-US" sz="1200" b="1" dirty="0">
+                <a:solidFill>
+                  <a:srgbClr val="00B050"/>
+                </a:solidFill>
+                <a:latin typeface="Consolas" panose="020B0609020204030204" pitchFamily="49" charset="0"/>
+                <a:cs typeface="Consolas" panose="020B0609020204030204" pitchFamily="49" charset="0"/>
+              </a:rPr>
+              <a:t># P = 0.0546875</a:t>
+            </a:r>
+          </a:p>
+          <a:p>
+            <a:r>
+              <a:rPr lang="en-US" sz="1200" b="1" dirty="0">
+                <a:solidFill>
+                  <a:srgbClr val="00B050"/>
+                </a:solidFill>
+                <a:latin typeface="Consolas" panose="020B0609020204030204" pitchFamily="49" charset="0"/>
+                <a:cs typeface="Consolas" panose="020B0609020204030204" pitchFamily="49" charset="0"/>
+              </a:rPr>
+              <a:t># Because this p-value (0.0546875) is not less than 0.05, </a:t>
+            </a:r>
+          </a:p>
+          <a:p>
+            <a:r>
+              <a:rPr lang="en-US" sz="1200" b="1" dirty="0">
+                <a:solidFill>
+                  <a:srgbClr val="00B050"/>
+                </a:solidFill>
+                <a:latin typeface="Consolas" panose="020B0609020204030204" pitchFamily="49" charset="0"/>
+                <a:cs typeface="Consolas" panose="020B0609020204030204" pitchFamily="49" charset="0"/>
+              </a:rPr>
+              <a:t># we accept the null hypothesis.</a:t>
+            </a:r>
+          </a:p>
+        </p:txBody>
+      </p:sp>
+      <p:cxnSp>
+        <p:nvCxnSpPr>
+          <p:cNvPr id="7" name="Straight Connector 6">
+            <a:extLst>
+              <a:ext uri="{FF2B5EF4-FFF2-40B4-BE49-F238E27FC236}">
+                <a16:creationId xmlns:a16="http://schemas.microsoft.com/office/drawing/2014/main" id="{CC869036-FE0F-1E47-8797-6B95E97124CA}"/>
+              </a:ext>
+            </a:extLst>
+          </p:cNvPr>
+          <p:cNvCxnSpPr/>
+          <p:nvPr/>
+        </p:nvCxnSpPr>
+        <p:spPr>
+          <a:xfrm>
+            <a:off x="3953437" y="246221"/>
+            <a:ext cx="0" cy="6369732"/>
+          </a:xfrm>
+          <a:prstGeom prst="line">
+            <a:avLst/>
+          </a:prstGeom>
+          <a:ln w="63500"/>
         </p:spPr>
         <p:style>
-          <a:lnRef idx="2">
-            <a:schemeClr val="accent1">
-              <a:shade val="50000"/>
-            </a:schemeClr>
+          <a:lnRef idx="1">
+            <a:schemeClr val="accent1"/>
           </a:lnRef>
-          <a:fillRef idx="1">
+          <a:fillRef idx="0">
             <a:schemeClr val="accent1"/>
           </a:fillRef>
           <a:effectRef idx="0">
             <a:schemeClr val="accent1"/>
           </a:effectRef>
           <a:fontRef idx="minor">
-            <a:schemeClr val="lt1"/>
+            <a:schemeClr val="tx1"/>
           </a:fontRef>
         </p:style>
+      </p:cxnSp>
+      <p:sp>
+        <p:nvSpPr>
+          <p:cNvPr id="14" name="TextBox 13">
+            <a:extLst>
+              <a:ext uri="{FF2B5EF4-FFF2-40B4-BE49-F238E27FC236}">
+                <a16:creationId xmlns:a16="http://schemas.microsoft.com/office/drawing/2014/main" id="{7E734F07-84EA-3747-B35F-8BE91031CC62}"/>
+              </a:ext>
+            </a:extLst>
+          </p:cNvPr>
+          <p:cNvSpPr txBox="1"/>
+          <p:nvPr/>
+        </p:nvSpPr>
+        <p:spPr>
+          <a:xfrm>
+            <a:off x="6128888" y="4149859"/>
+            <a:ext cx="5885361" cy="1015663"/>
+          </a:xfrm>
+          <a:prstGeom prst="rect">
+            <a:avLst/>
+          </a:prstGeom>
+          <a:noFill/>
+        </p:spPr>
         <p:txBody>
-          <a:bodyPr rtlCol="0" anchor="ctr"/>
+          <a:bodyPr wrap="square" rtlCol="0">
+            <a:spAutoFit/>
+          </a:bodyPr>
           <a:lstStyle/>
           <a:p>
-            <a:pPr algn="ctr"/>
-            <a:endParaRPr lang="en-US"/>
+            <a:r>
+              <a:rPr lang="en-US" sz="1200" b="1" dirty="0" err="1">
+                <a:solidFill>
+                  <a:srgbClr val="0070C0"/>
+                </a:solidFill>
+                <a:latin typeface="Consolas" panose="020B0609020204030204" pitchFamily="49" charset="0"/>
+                <a:cs typeface="Consolas" panose="020B0609020204030204" pitchFamily="49" charset="0"/>
+              </a:rPr>
+              <a:t>binom_test</a:t>
+            </a:r>
+            <a:r>
+              <a:rPr lang="en-US" sz="1200" b="1" dirty="0">
+                <a:solidFill>
+                  <a:srgbClr val="0070C0"/>
+                </a:solidFill>
+                <a:latin typeface="Consolas" panose="020B0609020204030204" pitchFamily="49" charset="0"/>
+                <a:cs typeface="Consolas" panose="020B0609020204030204" pitchFamily="49" charset="0"/>
+              </a:rPr>
+              <a:t>(x=0,   n=1000, p=1/2, alternative='two-sided')  </a:t>
+            </a:r>
+            <a:r>
+              <a:rPr lang="en-US" sz="1200" b="1" dirty="0">
+                <a:solidFill>
+                  <a:srgbClr val="00B050"/>
+                </a:solidFill>
+                <a:latin typeface="Consolas" panose="020B0609020204030204" pitchFamily="49" charset="0"/>
+                <a:cs typeface="Consolas" panose="020B0609020204030204" pitchFamily="49" charset="0"/>
+              </a:rPr>
+              <a:t># 0</a:t>
+            </a:r>
+          </a:p>
+          <a:p>
+            <a:r>
+              <a:rPr lang="en-US" sz="1200" b="1" dirty="0" err="1">
+                <a:solidFill>
+                  <a:srgbClr val="0070C0"/>
+                </a:solidFill>
+                <a:latin typeface="Consolas" panose="020B0609020204030204" pitchFamily="49" charset="0"/>
+                <a:cs typeface="Consolas" panose="020B0609020204030204" pitchFamily="49" charset="0"/>
+              </a:rPr>
+              <a:t>binom_test</a:t>
+            </a:r>
+            <a:r>
+              <a:rPr lang="en-US" sz="1200" b="1" dirty="0">
+                <a:solidFill>
+                  <a:srgbClr val="0070C0"/>
+                </a:solidFill>
+                <a:latin typeface="Consolas" panose="020B0609020204030204" pitchFamily="49" charset="0"/>
+                <a:cs typeface="Consolas" panose="020B0609020204030204" pitchFamily="49" charset="0"/>
+              </a:rPr>
+              <a:t>(x=470, n=1000, p=1/2, alternative='two-sided')  </a:t>
+            </a:r>
+            <a:r>
+              <a:rPr lang="en-US" sz="1200" b="1" dirty="0">
+                <a:solidFill>
+                  <a:srgbClr val="00B050"/>
+                </a:solidFill>
+                <a:latin typeface="Consolas" panose="020B0609020204030204" pitchFamily="49" charset="0"/>
+                <a:cs typeface="Consolas" panose="020B0609020204030204" pitchFamily="49" charset="0"/>
+              </a:rPr>
+              <a:t># 0.062</a:t>
+            </a:r>
+          </a:p>
+          <a:p>
+            <a:r>
+              <a:rPr lang="en-US" sz="1200" b="1" dirty="0" err="1">
+                <a:solidFill>
+                  <a:srgbClr val="0070C0"/>
+                </a:solidFill>
+                <a:latin typeface="Consolas" panose="020B0609020204030204" pitchFamily="49" charset="0"/>
+                <a:cs typeface="Consolas" panose="020B0609020204030204" pitchFamily="49" charset="0"/>
+              </a:rPr>
+              <a:t>binom_test</a:t>
+            </a:r>
+            <a:r>
+              <a:rPr lang="en-US" sz="1200" b="1" dirty="0">
+                <a:solidFill>
+                  <a:srgbClr val="0070C0"/>
+                </a:solidFill>
+                <a:latin typeface="Consolas" panose="020B0609020204030204" pitchFamily="49" charset="0"/>
+                <a:cs typeface="Consolas" panose="020B0609020204030204" pitchFamily="49" charset="0"/>
+              </a:rPr>
+              <a:t>(x=500, n=1000, p=1/2, alternative='two-sided')  </a:t>
+            </a:r>
+            <a:r>
+              <a:rPr lang="en-US" sz="1200" b="1" dirty="0">
+                <a:solidFill>
+                  <a:srgbClr val="00B050"/>
+                </a:solidFill>
+                <a:latin typeface="Consolas" panose="020B0609020204030204" pitchFamily="49" charset="0"/>
+                <a:cs typeface="Consolas" panose="020B0609020204030204" pitchFamily="49" charset="0"/>
+              </a:rPr>
+              <a:t># 1.0</a:t>
+            </a:r>
+          </a:p>
+          <a:p>
+            <a:r>
+              <a:rPr lang="en-US" sz="1200" b="1" dirty="0" err="1">
+                <a:solidFill>
+                  <a:srgbClr val="0070C0"/>
+                </a:solidFill>
+                <a:latin typeface="Consolas" panose="020B0609020204030204" pitchFamily="49" charset="0"/>
+                <a:cs typeface="Consolas" panose="020B0609020204030204" pitchFamily="49" charset="0"/>
+              </a:rPr>
+              <a:t>binom_test</a:t>
+            </a:r>
+            <a:r>
+              <a:rPr lang="en-US" sz="1200" b="1" dirty="0">
+                <a:solidFill>
+                  <a:srgbClr val="0070C0"/>
+                </a:solidFill>
+                <a:latin typeface="Consolas" panose="020B0609020204030204" pitchFamily="49" charset="0"/>
+                <a:cs typeface="Consolas" panose="020B0609020204030204" pitchFamily="49" charset="0"/>
+              </a:rPr>
+              <a:t>(x=530, n=1000, p=1/2, alternative='two-sided')  </a:t>
+            </a:r>
+            <a:r>
+              <a:rPr lang="en-US" sz="1200" b="1" dirty="0">
+                <a:solidFill>
+                  <a:srgbClr val="00B050"/>
+                </a:solidFill>
+                <a:latin typeface="Consolas" panose="020B0609020204030204" pitchFamily="49" charset="0"/>
+                <a:cs typeface="Consolas" panose="020B0609020204030204" pitchFamily="49" charset="0"/>
+              </a:rPr>
+              <a:t># 0.062</a:t>
+            </a:r>
+          </a:p>
+          <a:p>
+            <a:r>
+              <a:rPr lang="en-US" sz="1200" b="1" dirty="0" err="1">
+                <a:solidFill>
+                  <a:srgbClr val="0070C0"/>
+                </a:solidFill>
+                <a:latin typeface="Consolas" panose="020B0609020204030204" pitchFamily="49" charset="0"/>
+                <a:cs typeface="Consolas" panose="020B0609020204030204" pitchFamily="49" charset="0"/>
+              </a:rPr>
+              <a:t>binom_test</a:t>
+            </a:r>
+            <a:r>
+              <a:rPr lang="en-US" sz="1200" b="1" dirty="0">
+                <a:solidFill>
+                  <a:srgbClr val="0070C0"/>
+                </a:solidFill>
+                <a:latin typeface="Consolas" panose="020B0609020204030204" pitchFamily="49" charset="0"/>
+                <a:cs typeface="Consolas" panose="020B0609020204030204" pitchFamily="49" charset="0"/>
+              </a:rPr>
+              <a:t>(x=999, n=1000, p=1/2, alternative='two-sided')  </a:t>
+            </a:r>
+            <a:r>
+              <a:rPr lang="en-US" sz="1200" b="1" dirty="0">
+                <a:solidFill>
+                  <a:srgbClr val="00B050"/>
+                </a:solidFill>
+                <a:latin typeface="Consolas" panose="020B0609020204030204" pitchFamily="49" charset="0"/>
+                <a:cs typeface="Consolas" panose="020B0609020204030204" pitchFamily="49" charset="0"/>
+              </a:rPr>
+              <a:t># 0</a:t>
+            </a:r>
+          </a:p>
+        </p:txBody>
+      </p:sp>
+      <p:pic>
+        <p:nvPicPr>
+          <p:cNvPr id="15" name="Picture 14">
+            <a:extLst>
+              <a:ext uri="{FF2B5EF4-FFF2-40B4-BE49-F238E27FC236}">
+                <a16:creationId xmlns:a16="http://schemas.microsoft.com/office/drawing/2014/main" id="{86071A22-B3DB-A94F-8B3F-C3E70C2146C1}"/>
+              </a:ext>
+            </a:extLst>
+          </p:cNvPr>
+          <p:cNvPicPr>
+            <a:picLocks noChangeAspect="1"/>
+          </p:cNvPicPr>
+          <p:nvPr/>
+        </p:nvPicPr>
+        <p:blipFill>
+          <a:blip r:embed="rId4" cstate="email">
+            <a:extLst>
+              <a:ext uri="{28A0092B-C50C-407E-A947-70E740481C1C}">
+                <a14:useLocalDpi xmlns:a14="http://schemas.microsoft.com/office/drawing/2010/main"/>
+              </a:ext>
+            </a:extLst>
+          </a:blip>
+          <a:stretch>
+            <a:fillRect/>
+          </a:stretch>
+        </p:blipFill>
+        <p:spPr>
+          <a:xfrm>
+            <a:off x="4107674" y="4052375"/>
+            <a:ext cx="1955444" cy="1303629"/>
+          </a:xfrm>
+          <a:prstGeom prst="rect">
+            <a:avLst/>
+          </a:prstGeom>
+        </p:spPr>
+      </p:pic>
+      <p:sp>
+        <p:nvSpPr>
+          <p:cNvPr id="16" name="TextBox 15">
+            <a:extLst>
+              <a:ext uri="{FF2B5EF4-FFF2-40B4-BE49-F238E27FC236}">
+                <a16:creationId xmlns:a16="http://schemas.microsoft.com/office/drawing/2014/main" id="{D511F09B-6968-D94E-AA08-C85D9DF4BB1F}"/>
+              </a:ext>
+            </a:extLst>
+          </p:cNvPr>
+          <p:cNvSpPr txBox="1"/>
+          <p:nvPr/>
+        </p:nvSpPr>
+        <p:spPr>
+          <a:xfrm>
+            <a:off x="55090" y="2538720"/>
+            <a:ext cx="3871452" cy="3970318"/>
+          </a:xfrm>
+          <a:prstGeom prst="rect">
+            <a:avLst/>
+          </a:prstGeom>
+          <a:noFill/>
+        </p:spPr>
+        <p:txBody>
+          <a:bodyPr wrap="square" rtlCol="0">
+            <a:spAutoFit/>
+          </a:bodyPr>
+          <a:lstStyle/>
+          <a:p>
+            <a:r>
+              <a:rPr lang="en-US" dirty="0">
+                <a:solidFill>
+                  <a:srgbClr val="0070C0"/>
+                </a:solidFill>
+                <a:latin typeface="Consolas" panose="020B0609020204030204" pitchFamily="49" charset="0"/>
+                <a:cs typeface="Consolas" panose="020B0609020204030204" pitchFamily="49" charset="0"/>
+              </a:rPr>
+              <a:t>from </a:t>
+            </a:r>
+            <a:r>
+              <a:rPr lang="en-US" dirty="0" err="1">
+                <a:solidFill>
+                  <a:srgbClr val="0070C0"/>
+                </a:solidFill>
+                <a:latin typeface="Consolas" panose="020B0609020204030204" pitchFamily="49" charset="0"/>
+                <a:cs typeface="Consolas" panose="020B0609020204030204" pitchFamily="49" charset="0"/>
+              </a:rPr>
+              <a:t>scipy.stats</a:t>
+            </a:r>
+            <a:r>
+              <a:rPr lang="en-US" dirty="0">
+                <a:solidFill>
+                  <a:srgbClr val="0070C0"/>
+                </a:solidFill>
+                <a:latin typeface="Consolas" panose="020B0609020204030204" pitchFamily="49" charset="0"/>
+                <a:cs typeface="Consolas" panose="020B0609020204030204" pitchFamily="49" charset="0"/>
+              </a:rPr>
+              <a:t> import </a:t>
+            </a:r>
+            <a:r>
+              <a:rPr lang="en-US" dirty="0" err="1">
+                <a:solidFill>
+                  <a:srgbClr val="0070C0"/>
+                </a:solidFill>
+                <a:latin typeface="Consolas" panose="020B0609020204030204" pitchFamily="49" charset="0"/>
+                <a:cs typeface="Consolas" panose="020B0609020204030204" pitchFamily="49" charset="0"/>
+              </a:rPr>
+              <a:t>binom</a:t>
+            </a:r>
+            <a:r>
+              <a:rPr lang="en-US" dirty="0">
+                <a:solidFill>
+                  <a:srgbClr val="0070C0"/>
+                </a:solidFill>
+                <a:latin typeface="Consolas" panose="020B0609020204030204" pitchFamily="49" charset="0"/>
+                <a:cs typeface="Consolas" panose="020B0609020204030204" pitchFamily="49" charset="0"/>
+              </a:rPr>
+              <a:t> </a:t>
+            </a:r>
+          </a:p>
+          <a:p>
+            <a:endParaRPr lang="en-US" b="1" dirty="0">
+              <a:solidFill>
+                <a:srgbClr val="00B050"/>
+              </a:solidFill>
+              <a:latin typeface="Consolas" panose="020B0609020204030204" pitchFamily="49" charset="0"/>
+              <a:cs typeface="Consolas" panose="020B0609020204030204" pitchFamily="49" charset="0"/>
+            </a:endParaRPr>
+          </a:p>
+          <a:p>
+            <a:r>
+              <a:rPr lang="en-US" dirty="0" err="1">
+                <a:solidFill>
+                  <a:srgbClr val="0070C0"/>
+                </a:solidFill>
+                <a:latin typeface="Consolas" panose="020B0609020204030204" pitchFamily="49" charset="0"/>
+                <a:cs typeface="Consolas" panose="020B0609020204030204" pitchFamily="49" charset="0"/>
+              </a:rPr>
+              <a:t>binom.pmf</a:t>
+            </a:r>
+            <a:r>
+              <a:rPr lang="en-US" dirty="0">
+                <a:solidFill>
+                  <a:srgbClr val="0070C0"/>
+                </a:solidFill>
+                <a:latin typeface="Consolas" panose="020B0609020204030204" pitchFamily="49" charset="0"/>
+                <a:cs typeface="Consolas" panose="020B0609020204030204" pitchFamily="49" charset="0"/>
+              </a:rPr>
+              <a:t>(0,2,0.5) </a:t>
+            </a:r>
+            <a:r>
+              <a:rPr lang="en-US" b="1" dirty="0">
+                <a:solidFill>
+                  <a:srgbClr val="00B050"/>
+                </a:solidFill>
+                <a:latin typeface="Consolas" panose="020B0609020204030204" pitchFamily="49" charset="0"/>
+                <a:cs typeface="Consolas" panose="020B0609020204030204" pitchFamily="49" charset="0"/>
+              </a:rPr>
+              <a:t># 0.25</a:t>
+            </a:r>
+          </a:p>
+          <a:p>
+            <a:r>
+              <a:rPr lang="en-US" dirty="0" err="1">
+                <a:solidFill>
+                  <a:srgbClr val="0070C0"/>
+                </a:solidFill>
+                <a:latin typeface="Consolas" panose="020B0609020204030204" pitchFamily="49" charset="0"/>
+                <a:cs typeface="Consolas" panose="020B0609020204030204" pitchFamily="49" charset="0"/>
+              </a:rPr>
+              <a:t>binom.pmf</a:t>
+            </a:r>
+            <a:r>
+              <a:rPr lang="en-US" dirty="0">
+                <a:solidFill>
+                  <a:srgbClr val="0070C0"/>
+                </a:solidFill>
+                <a:latin typeface="Consolas" panose="020B0609020204030204" pitchFamily="49" charset="0"/>
+                <a:cs typeface="Consolas" panose="020B0609020204030204" pitchFamily="49" charset="0"/>
+              </a:rPr>
+              <a:t>(1,2,0.5) </a:t>
+            </a:r>
+            <a:r>
+              <a:rPr lang="en-US" b="1" dirty="0">
+                <a:solidFill>
+                  <a:srgbClr val="00B050"/>
+                </a:solidFill>
+                <a:latin typeface="Consolas" panose="020B0609020204030204" pitchFamily="49" charset="0"/>
+                <a:cs typeface="Consolas" panose="020B0609020204030204" pitchFamily="49" charset="0"/>
+              </a:rPr>
+              <a:t># 0.5</a:t>
+            </a:r>
+          </a:p>
+          <a:p>
+            <a:r>
+              <a:rPr lang="en-US" dirty="0" err="1">
+                <a:solidFill>
+                  <a:srgbClr val="0070C0"/>
+                </a:solidFill>
+                <a:latin typeface="Consolas" panose="020B0609020204030204" pitchFamily="49" charset="0"/>
+                <a:cs typeface="Consolas" panose="020B0609020204030204" pitchFamily="49" charset="0"/>
+              </a:rPr>
+              <a:t>binom.pmf</a:t>
+            </a:r>
+            <a:r>
+              <a:rPr lang="en-US" dirty="0">
+                <a:solidFill>
+                  <a:srgbClr val="0070C0"/>
+                </a:solidFill>
+                <a:latin typeface="Consolas" panose="020B0609020204030204" pitchFamily="49" charset="0"/>
+                <a:cs typeface="Consolas" panose="020B0609020204030204" pitchFamily="49" charset="0"/>
+              </a:rPr>
+              <a:t>(2,2,0.5) </a:t>
+            </a:r>
+            <a:r>
+              <a:rPr lang="en-US" b="1" dirty="0">
+                <a:solidFill>
+                  <a:srgbClr val="00B050"/>
+                </a:solidFill>
+                <a:latin typeface="Consolas" panose="020B0609020204030204" pitchFamily="49" charset="0"/>
+                <a:cs typeface="Consolas" panose="020B0609020204030204" pitchFamily="49" charset="0"/>
+              </a:rPr>
+              <a:t># 0.25</a:t>
+            </a:r>
+          </a:p>
+          <a:p>
+            <a:endParaRPr lang="en-US" b="1" dirty="0">
+              <a:solidFill>
+                <a:srgbClr val="00B050"/>
+              </a:solidFill>
+              <a:latin typeface="Consolas" panose="020B0609020204030204" pitchFamily="49" charset="0"/>
+              <a:cs typeface="Consolas" panose="020B0609020204030204" pitchFamily="49" charset="0"/>
+            </a:endParaRPr>
+          </a:p>
+          <a:p>
+            <a:r>
+              <a:rPr lang="en-US" dirty="0">
+                <a:solidFill>
+                  <a:srgbClr val="0070C0"/>
+                </a:solidFill>
+                <a:latin typeface="Consolas" panose="020B0609020204030204" pitchFamily="49" charset="0"/>
+                <a:cs typeface="Consolas" panose="020B0609020204030204" pitchFamily="49" charset="0"/>
+              </a:rPr>
+              <a:t>n=10</a:t>
+            </a:r>
+          </a:p>
+          <a:p>
+            <a:r>
+              <a:rPr lang="en-US" dirty="0" err="1">
+                <a:solidFill>
+                  <a:srgbClr val="0070C0"/>
+                </a:solidFill>
+                <a:latin typeface="Consolas" panose="020B0609020204030204" pitchFamily="49" charset="0"/>
+                <a:cs typeface="Consolas" panose="020B0609020204030204" pitchFamily="49" charset="0"/>
+              </a:rPr>
+              <a:t>arr</a:t>
+            </a:r>
+            <a:r>
+              <a:rPr lang="en-US" dirty="0">
+                <a:solidFill>
+                  <a:srgbClr val="0070C0"/>
+                </a:solidFill>
+                <a:latin typeface="Consolas" panose="020B0609020204030204" pitchFamily="49" charset="0"/>
+                <a:cs typeface="Consolas" panose="020B0609020204030204" pitchFamily="49" charset="0"/>
+              </a:rPr>
+              <a:t> = []</a:t>
+            </a:r>
+          </a:p>
+          <a:p>
+            <a:r>
+              <a:rPr lang="en-US" dirty="0">
+                <a:solidFill>
+                  <a:srgbClr val="0070C0"/>
+                </a:solidFill>
+                <a:latin typeface="Consolas" panose="020B0609020204030204" pitchFamily="49" charset="0"/>
+                <a:cs typeface="Consolas" panose="020B0609020204030204" pitchFamily="49" charset="0"/>
+              </a:rPr>
+              <a:t>for ii in range(n+1):</a:t>
+            </a:r>
+          </a:p>
+          <a:p>
+            <a:r>
+              <a:rPr lang="en-US" dirty="0">
+                <a:solidFill>
+                  <a:srgbClr val="0070C0"/>
+                </a:solidFill>
+                <a:latin typeface="Consolas" panose="020B0609020204030204" pitchFamily="49" charset="0"/>
+                <a:cs typeface="Consolas" panose="020B0609020204030204" pitchFamily="49" charset="0"/>
+              </a:rPr>
+              <a:t>    </a:t>
+            </a:r>
+            <a:r>
+              <a:rPr lang="en-US" dirty="0" err="1">
+                <a:solidFill>
+                  <a:srgbClr val="0070C0"/>
+                </a:solidFill>
+                <a:latin typeface="Consolas" panose="020B0609020204030204" pitchFamily="49" charset="0"/>
+                <a:cs typeface="Consolas" panose="020B0609020204030204" pitchFamily="49" charset="0"/>
+              </a:rPr>
+              <a:t>arr.append</a:t>
+            </a:r>
+            <a:r>
+              <a:rPr lang="en-US" dirty="0">
+                <a:solidFill>
+                  <a:srgbClr val="0070C0"/>
+                </a:solidFill>
+                <a:latin typeface="Consolas" panose="020B0609020204030204" pitchFamily="49" charset="0"/>
+                <a:cs typeface="Consolas" panose="020B0609020204030204" pitchFamily="49" charset="0"/>
+              </a:rPr>
+              <a:t>(</a:t>
+            </a:r>
+            <a:r>
+              <a:rPr lang="en-US" dirty="0" err="1">
+                <a:solidFill>
+                  <a:srgbClr val="0070C0"/>
+                </a:solidFill>
+                <a:latin typeface="Consolas" panose="020B0609020204030204" pitchFamily="49" charset="0"/>
+                <a:cs typeface="Consolas" panose="020B0609020204030204" pitchFamily="49" charset="0"/>
+              </a:rPr>
+              <a:t>binom.pmf</a:t>
+            </a:r>
+            <a:r>
+              <a:rPr lang="en-US" dirty="0">
+                <a:solidFill>
+                  <a:srgbClr val="0070C0"/>
+                </a:solidFill>
+                <a:latin typeface="Consolas" panose="020B0609020204030204" pitchFamily="49" charset="0"/>
+                <a:cs typeface="Consolas" panose="020B0609020204030204" pitchFamily="49" charset="0"/>
+              </a:rPr>
+              <a:t>(ii, n, 0.5))</a:t>
+            </a:r>
+          </a:p>
+          <a:p>
+            <a:r>
+              <a:rPr lang="en-US" dirty="0">
+                <a:solidFill>
+                  <a:srgbClr val="0070C0"/>
+                </a:solidFill>
+                <a:latin typeface="Consolas" panose="020B0609020204030204" pitchFamily="49" charset="0"/>
+                <a:cs typeface="Consolas" panose="020B0609020204030204" pitchFamily="49" charset="0"/>
+              </a:rPr>
+              <a:t>print(sum(</a:t>
+            </a:r>
+            <a:r>
+              <a:rPr lang="en-US" dirty="0" err="1">
+                <a:solidFill>
+                  <a:srgbClr val="0070C0"/>
+                </a:solidFill>
+                <a:latin typeface="Consolas" panose="020B0609020204030204" pitchFamily="49" charset="0"/>
+                <a:cs typeface="Consolas" panose="020B0609020204030204" pitchFamily="49" charset="0"/>
+              </a:rPr>
+              <a:t>arr</a:t>
+            </a:r>
+            <a:r>
+              <a:rPr lang="en-US" dirty="0">
+                <a:solidFill>
+                  <a:srgbClr val="0070C0"/>
+                </a:solidFill>
+                <a:latin typeface="Consolas" panose="020B0609020204030204" pitchFamily="49" charset="0"/>
+                <a:cs typeface="Consolas" panose="020B0609020204030204" pitchFamily="49" charset="0"/>
+              </a:rPr>
+              <a:t>))</a:t>
+            </a:r>
+            <a:r>
+              <a:rPr lang="en-US" b="1" dirty="0">
+                <a:solidFill>
+                  <a:srgbClr val="00B050"/>
+                </a:solidFill>
+                <a:latin typeface="Consolas" panose="020B0609020204030204" pitchFamily="49" charset="0"/>
+                <a:cs typeface="Consolas" panose="020B0609020204030204" pitchFamily="49" charset="0"/>
+              </a:rPr>
+              <a:t>  # 1</a:t>
+            </a:r>
+          </a:p>
+          <a:p>
+            <a:r>
+              <a:rPr lang="en-US" dirty="0">
+                <a:solidFill>
+                  <a:srgbClr val="0070C0"/>
+                </a:solidFill>
+                <a:latin typeface="Consolas" panose="020B0609020204030204" pitchFamily="49" charset="0"/>
+                <a:cs typeface="Consolas" panose="020B0609020204030204" pitchFamily="49" charset="0"/>
+              </a:rPr>
+              <a:t>print(</a:t>
+            </a:r>
+            <a:r>
+              <a:rPr lang="en-US" dirty="0" err="1">
+                <a:solidFill>
+                  <a:srgbClr val="0070C0"/>
+                </a:solidFill>
+                <a:latin typeface="Consolas" panose="020B0609020204030204" pitchFamily="49" charset="0"/>
+                <a:cs typeface="Consolas" panose="020B0609020204030204" pitchFamily="49" charset="0"/>
+              </a:rPr>
+              <a:t>arr</a:t>
+            </a:r>
+            <a:r>
+              <a:rPr lang="en-US" dirty="0">
+                <a:solidFill>
+                  <a:srgbClr val="0070C0"/>
+                </a:solidFill>
+                <a:latin typeface="Consolas" panose="020B0609020204030204" pitchFamily="49" charset="0"/>
+                <a:cs typeface="Consolas" panose="020B0609020204030204" pitchFamily="49" charset="0"/>
+              </a:rPr>
+              <a:t>)</a:t>
+            </a:r>
+          </a:p>
+          <a:p>
+            <a:endParaRPr lang="en-US" b="1" dirty="0">
+              <a:solidFill>
+                <a:srgbClr val="00B050"/>
+              </a:solidFill>
+              <a:latin typeface="Consolas" panose="020B0609020204030204" pitchFamily="49" charset="0"/>
+              <a:cs typeface="Consolas" panose="020B0609020204030204" pitchFamily="49" charset="0"/>
+            </a:endParaRPr>
+          </a:p>
+          <a:p>
+            <a:r>
+              <a:rPr lang="en-US" b="1" dirty="0">
+                <a:solidFill>
+                  <a:srgbClr val="00B050"/>
+                </a:solidFill>
+                <a:latin typeface="Consolas" panose="020B0609020204030204" pitchFamily="49" charset="0"/>
+                <a:cs typeface="Consolas" panose="020B0609020204030204" pitchFamily="49" charset="0"/>
+              </a:rPr>
+              <a:t># 8, 9, 10 heads out of 10 trials:</a:t>
+            </a:r>
+          </a:p>
+          <a:p>
+            <a:r>
+              <a:rPr lang="en-US" dirty="0" err="1">
+                <a:solidFill>
+                  <a:srgbClr val="0070C0"/>
+                </a:solidFill>
+                <a:latin typeface="Consolas" panose="020B0609020204030204" pitchFamily="49" charset="0"/>
+                <a:cs typeface="Consolas" panose="020B0609020204030204" pitchFamily="49" charset="0"/>
+              </a:rPr>
+              <a:t>binom.pmf</a:t>
+            </a:r>
+            <a:r>
+              <a:rPr lang="en-US" dirty="0">
+                <a:solidFill>
+                  <a:srgbClr val="0070C0"/>
+                </a:solidFill>
+                <a:latin typeface="Consolas" panose="020B0609020204030204" pitchFamily="49" charset="0"/>
+                <a:cs typeface="Consolas" panose="020B0609020204030204" pitchFamily="49" charset="0"/>
+              </a:rPr>
+              <a:t>(8,10,0.5)  # 0.043945</a:t>
+            </a:r>
+          </a:p>
+          <a:p>
+            <a:r>
+              <a:rPr lang="en-US" dirty="0" err="1">
+                <a:solidFill>
+                  <a:srgbClr val="0070C0"/>
+                </a:solidFill>
+                <a:latin typeface="Consolas" panose="020B0609020204030204" pitchFamily="49" charset="0"/>
+                <a:cs typeface="Consolas" panose="020B0609020204030204" pitchFamily="49" charset="0"/>
+              </a:rPr>
+              <a:t>binom.pmf</a:t>
+            </a:r>
+            <a:r>
+              <a:rPr lang="en-US" dirty="0">
+                <a:solidFill>
+                  <a:srgbClr val="0070C0"/>
+                </a:solidFill>
+                <a:latin typeface="Consolas" panose="020B0609020204030204" pitchFamily="49" charset="0"/>
+                <a:cs typeface="Consolas" panose="020B0609020204030204" pitchFamily="49" charset="0"/>
+              </a:rPr>
+              <a:t>(9,10,0.5)  # 0.009766</a:t>
+            </a:r>
+          </a:p>
+          <a:p>
+            <a:r>
+              <a:rPr lang="en-US" dirty="0" err="1">
+                <a:solidFill>
+                  <a:srgbClr val="0070C0"/>
+                </a:solidFill>
+                <a:latin typeface="Consolas" panose="020B0609020204030204" pitchFamily="49" charset="0"/>
+                <a:cs typeface="Consolas" panose="020B0609020204030204" pitchFamily="49" charset="0"/>
+              </a:rPr>
+              <a:t>binom.pmf</a:t>
+            </a:r>
+            <a:r>
+              <a:rPr lang="en-US" dirty="0">
+                <a:solidFill>
+                  <a:srgbClr val="0070C0"/>
+                </a:solidFill>
+                <a:latin typeface="Consolas" panose="020B0609020204030204" pitchFamily="49" charset="0"/>
+                <a:cs typeface="Consolas" panose="020B0609020204030204" pitchFamily="49" charset="0"/>
+              </a:rPr>
+              <a:t>(10,10,0.5) # 0.000977</a:t>
+            </a:r>
+          </a:p>
+          <a:p>
+            <a:r>
+              <a:rPr lang="en-US" dirty="0">
+                <a:solidFill>
+                  <a:srgbClr val="0070C0"/>
+                </a:solidFill>
+                <a:latin typeface="Consolas" panose="020B0609020204030204" pitchFamily="49" charset="0"/>
+                <a:cs typeface="Consolas" panose="020B0609020204030204" pitchFamily="49" charset="0"/>
+              </a:rPr>
+              <a:t>                # sum: 0.054688</a:t>
+            </a:r>
+          </a:p>
+        </p:txBody>
+      </p:sp>
+      <p:sp>
+        <p:nvSpPr>
+          <p:cNvPr id="17" name="TextBox 16">
+            <a:extLst>
+              <a:ext uri="{FF2B5EF4-FFF2-40B4-BE49-F238E27FC236}">
+                <a16:creationId xmlns:a16="http://schemas.microsoft.com/office/drawing/2014/main" id="{3AB7D7A0-D8BB-7D4C-9883-4005944A1DA6}"/>
+              </a:ext>
+            </a:extLst>
+          </p:cNvPr>
+          <p:cNvSpPr txBox="1"/>
+          <p:nvPr/>
+        </p:nvSpPr>
+        <p:spPr>
+          <a:xfrm>
+            <a:off x="4107674" y="131094"/>
+            <a:ext cx="7578799" cy="1200329"/>
+          </a:xfrm>
+          <a:prstGeom prst="rect">
+            <a:avLst/>
+          </a:prstGeom>
+          <a:noFill/>
+        </p:spPr>
+        <p:txBody>
+          <a:bodyPr wrap="square" rtlCol="0">
+            <a:spAutoFit/>
+          </a:bodyPr>
+          <a:lstStyle/>
+          <a:p>
+            <a:r>
+              <a:rPr lang="en-US" sz="1200" b="1" dirty="0">
+                <a:solidFill>
+                  <a:srgbClr val="00B050"/>
+                </a:solidFill>
+                <a:latin typeface="Consolas" panose="020B0609020204030204" pitchFamily="49" charset="0"/>
+                <a:cs typeface="Consolas" panose="020B0609020204030204" pitchFamily="49" charset="0"/>
+              </a:rPr>
+              <a:t># We flip a coin N=1000 times.</a:t>
+            </a:r>
+          </a:p>
+          <a:p>
+            <a:r>
+              <a:rPr lang="en-US" sz="1200" b="1" dirty="0">
+                <a:solidFill>
+                  <a:srgbClr val="00B050"/>
+                </a:solidFill>
+                <a:latin typeface="Consolas" panose="020B0609020204030204" pitchFamily="49" charset="0"/>
+                <a:cs typeface="Consolas" panose="020B0609020204030204" pitchFamily="49" charset="0"/>
+              </a:rPr>
+              <a:t># If x is number of heads, it has binomial distribution with sigma = sqrt(N)/2 = 15.81</a:t>
+            </a:r>
+          </a:p>
+          <a:p>
+            <a:r>
+              <a:rPr lang="en-US" sz="1200" b="1" dirty="0">
+                <a:solidFill>
+                  <a:srgbClr val="00B050"/>
+                </a:solidFill>
+                <a:latin typeface="Consolas" panose="020B0609020204030204" pitchFamily="49" charset="0"/>
+                <a:cs typeface="Consolas" panose="020B0609020204030204" pitchFamily="49" charset="0"/>
+              </a:rPr>
+              <a:t># If it lands on heads 531 times, it is within 2*sigma. </a:t>
+            </a:r>
+          </a:p>
+          <a:p>
+            <a:r>
+              <a:rPr lang="en-US" sz="1200" b="1" dirty="0">
+                <a:solidFill>
+                  <a:srgbClr val="00B050"/>
+                </a:solidFill>
+                <a:latin typeface="Consolas" panose="020B0609020204030204" pitchFamily="49" charset="0"/>
+                <a:cs typeface="Consolas" panose="020B0609020204030204" pitchFamily="49" charset="0"/>
+              </a:rPr>
+              <a:t># But let's perform a binomial test for null hypothesis that coin is fair:</a:t>
+            </a:r>
+          </a:p>
+          <a:p>
+            <a:r>
+              <a:rPr lang="en-US" sz="1200" b="1" dirty="0" err="1">
+                <a:solidFill>
+                  <a:srgbClr val="0070C0"/>
+                </a:solidFill>
+                <a:latin typeface="Consolas" panose="020B0609020204030204" pitchFamily="49" charset="0"/>
+                <a:cs typeface="Consolas" panose="020B0609020204030204" pitchFamily="49" charset="0"/>
+              </a:rPr>
+              <a:t>binom_test</a:t>
+            </a:r>
+            <a:r>
+              <a:rPr lang="en-US" sz="1200" b="1" dirty="0">
+                <a:solidFill>
+                  <a:srgbClr val="0070C0"/>
+                </a:solidFill>
+                <a:latin typeface="Consolas" panose="020B0609020204030204" pitchFamily="49" charset="0"/>
+                <a:cs typeface="Consolas" panose="020B0609020204030204" pitchFamily="49" charset="0"/>
+              </a:rPr>
+              <a:t>(x=531, n=1000, p=1/2, alternative='greater') </a:t>
+            </a:r>
+            <a:r>
+              <a:rPr lang="en-US" sz="1200" b="1" dirty="0">
+                <a:solidFill>
+                  <a:srgbClr val="00B050"/>
+                </a:solidFill>
+                <a:latin typeface="Consolas" panose="020B0609020204030204" pitchFamily="49" charset="0"/>
+                <a:cs typeface="Consolas" panose="020B0609020204030204" pitchFamily="49" charset="0"/>
+              </a:rPr>
+              <a:t># P = 0.0268</a:t>
+            </a:r>
+          </a:p>
+          <a:p>
+            <a:r>
+              <a:rPr lang="en-US" sz="1200" b="1" dirty="0">
+                <a:solidFill>
+                  <a:srgbClr val="00B050"/>
+                </a:solidFill>
+                <a:latin typeface="Consolas" panose="020B0609020204030204" pitchFamily="49" charset="0"/>
+                <a:cs typeface="Consolas" panose="020B0609020204030204" pitchFamily="49" charset="0"/>
+              </a:rPr>
+              <a:t># Because this p-value (0.0268) is less than 0.05, we reject the null hypothesis.</a:t>
+            </a:r>
+          </a:p>
+        </p:txBody>
+      </p:sp>
+      <p:pic>
+        <p:nvPicPr>
+          <p:cNvPr id="18" name="Picture 17">
+            <a:extLst>
+              <a:ext uri="{FF2B5EF4-FFF2-40B4-BE49-F238E27FC236}">
+                <a16:creationId xmlns:a16="http://schemas.microsoft.com/office/drawing/2014/main" id="{F0E66C0F-DB7B-5248-ABF5-B1AD675C2E7D}"/>
+              </a:ext>
+            </a:extLst>
+          </p:cNvPr>
+          <p:cNvPicPr>
+            <a:picLocks noChangeAspect="1"/>
+          </p:cNvPicPr>
+          <p:nvPr/>
+        </p:nvPicPr>
+        <p:blipFill>
+          <a:blip r:embed="rId5" cstate="email">
+            <a:extLst>
+              <a:ext uri="{28A0092B-C50C-407E-A947-70E740481C1C}">
+                <a14:useLocalDpi xmlns:a14="http://schemas.microsoft.com/office/drawing/2010/main"/>
+              </a:ext>
+            </a:extLst>
+          </a:blip>
+          <a:stretch>
+            <a:fillRect/>
+          </a:stretch>
+        </p:blipFill>
+        <p:spPr>
+          <a:xfrm>
+            <a:off x="4107674" y="1489196"/>
+            <a:ext cx="1955442" cy="1303628"/>
+          </a:xfrm>
+          <a:prstGeom prst="rect">
+            <a:avLst/>
+          </a:prstGeom>
+        </p:spPr>
+      </p:pic>
+      <p:sp>
+        <p:nvSpPr>
+          <p:cNvPr id="19" name="TextBox 18">
+            <a:extLst>
+              <a:ext uri="{FF2B5EF4-FFF2-40B4-BE49-F238E27FC236}">
+                <a16:creationId xmlns:a16="http://schemas.microsoft.com/office/drawing/2014/main" id="{23B13AD1-74A9-4B45-9F1F-80C123028C44}"/>
+              </a:ext>
+            </a:extLst>
+          </p:cNvPr>
+          <p:cNvSpPr txBox="1"/>
+          <p:nvPr/>
+        </p:nvSpPr>
+        <p:spPr>
+          <a:xfrm>
+            <a:off x="6128884" y="1282539"/>
+            <a:ext cx="5885365" cy="1384995"/>
+          </a:xfrm>
+          <a:prstGeom prst="rect">
+            <a:avLst/>
+          </a:prstGeom>
+          <a:noFill/>
+        </p:spPr>
+        <p:txBody>
+          <a:bodyPr wrap="square" rtlCol="0">
+            <a:spAutoFit/>
+          </a:bodyPr>
+          <a:lstStyle/>
+          <a:p>
+            <a:r>
+              <a:rPr lang="en-US" sz="1200" b="1" dirty="0">
+                <a:solidFill>
+                  <a:srgbClr val="0070C0"/>
+                </a:solidFill>
+                <a:latin typeface="Consolas" panose="020B0609020204030204" pitchFamily="49" charset="0"/>
+                <a:cs typeface="Consolas" panose="020B0609020204030204" pitchFamily="49" charset="0"/>
+              </a:rPr>
+              <a:t>from </a:t>
+            </a:r>
+            <a:r>
+              <a:rPr lang="en-US" sz="1200" b="1" dirty="0" err="1">
+                <a:solidFill>
+                  <a:srgbClr val="0070C0"/>
+                </a:solidFill>
+                <a:latin typeface="Consolas" panose="020B0609020204030204" pitchFamily="49" charset="0"/>
+                <a:cs typeface="Consolas" panose="020B0609020204030204" pitchFamily="49" charset="0"/>
+              </a:rPr>
+              <a:t>scipy.stats</a:t>
+            </a:r>
+            <a:r>
+              <a:rPr lang="en-US" sz="1200" b="1" dirty="0">
+                <a:solidFill>
+                  <a:srgbClr val="0070C0"/>
+                </a:solidFill>
+                <a:latin typeface="Consolas" panose="020B0609020204030204" pitchFamily="49" charset="0"/>
+                <a:cs typeface="Consolas" panose="020B0609020204030204" pitchFamily="49" charset="0"/>
+              </a:rPr>
+              <a:t> import </a:t>
+            </a:r>
+            <a:r>
+              <a:rPr lang="en-US" sz="1200" b="1" dirty="0" err="1">
+                <a:solidFill>
+                  <a:srgbClr val="0070C0"/>
+                </a:solidFill>
+                <a:latin typeface="Consolas" panose="020B0609020204030204" pitchFamily="49" charset="0"/>
+                <a:cs typeface="Consolas" panose="020B0609020204030204" pitchFamily="49" charset="0"/>
+              </a:rPr>
+              <a:t>binom_test</a:t>
+            </a:r>
+            <a:r>
+              <a:rPr lang="en-US" sz="1200" b="1" dirty="0">
+                <a:solidFill>
+                  <a:srgbClr val="00B050"/>
+                </a:solidFill>
+                <a:latin typeface="Consolas" panose="020B0609020204030204" pitchFamily="49" charset="0"/>
+                <a:cs typeface="Consolas" panose="020B0609020204030204" pitchFamily="49" charset="0"/>
+              </a:rPr>
+              <a:t>  # returns p-value of test</a:t>
+            </a:r>
+          </a:p>
+          <a:p>
+            <a:endParaRPr lang="en-US" sz="1200" b="1" dirty="0">
+              <a:solidFill>
+                <a:srgbClr val="0070C0"/>
+              </a:solidFill>
+              <a:latin typeface="Consolas" panose="020B0609020204030204" pitchFamily="49" charset="0"/>
+              <a:cs typeface="Consolas" panose="020B0609020204030204" pitchFamily="49" charset="0"/>
+            </a:endParaRPr>
+          </a:p>
+          <a:p>
+            <a:r>
+              <a:rPr lang="en-US" sz="1200" b="1" dirty="0" err="1">
+                <a:solidFill>
+                  <a:srgbClr val="0070C0"/>
+                </a:solidFill>
+                <a:latin typeface="Consolas" panose="020B0609020204030204" pitchFamily="49" charset="0"/>
+                <a:cs typeface="Consolas" panose="020B0609020204030204" pitchFamily="49" charset="0"/>
+              </a:rPr>
+              <a:t>binom_test</a:t>
+            </a:r>
+            <a:r>
+              <a:rPr lang="en-US" sz="1200" b="1" dirty="0">
+                <a:solidFill>
+                  <a:srgbClr val="0070C0"/>
+                </a:solidFill>
+                <a:latin typeface="Consolas" panose="020B0609020204030204" pitchFamily="49" charset="0"/>
+                <a:cs typeface="Consolas" panose="020B0609020204030204" pitchFamily="49" charset="0"/>
+              </a:rPr>
+              <a:t>(x=0,   n=1000, p=1/2, alternative='less')  </a:t>
+            </a:r>
+            <a:r>
+              <a:rPr lang="en-US" sz="1200" b="1" dirty="0">
+                <a:solidFill>
+                  <a:srgbClr val="00B050"/>
+                </a:solidFill>
+                <a:latin typeface="Consolas" panose="020B0609020204030204" pitchFamily="49" charset="0"/>
+                <a:cs typeface="Consolas" panose="020B0609020204030204" pitchFamily="49" charset="0"/>
+              </a:rPr>
+              <a:t># 1</a:t>
+            </a:r>
+          </a:p>
+          <a:p>
+            <a:r>
+              <a:rPr lang="en-US" sz="1200" b="1" dirty="0" err="1">
+                <a:solidFill>
+                  <a:srgbClr val="0070C0"/>
+                </a:solidFill>
+                <a:latin typeface="Consolas" panose="020B0609020204030204" pitchFamily="49" charset="0"/>
+                <a:cs typeface="Consolas" panose="020B0609020204030204" pitchFamily="49" charset="0"/>
+              </a:rPr>
+              <a:t>binom_test</a:t>
+            </a:r>
+            <a:r>
+              <a:rPr lang="en-US" sz="1200" b="1" dirty="0">
+                <a:solidFill>
+                  <a:srgbClr val="0070C0"/>
+                </a:solidFill>
+                <a:latin typeface="Consolas" panose="020B0609020204030204" pitchFamily="49" charset="0"/>
+                <a:cs typeface="Consolas" panose="020B0609020204030204" pitchFamily="49" charset="0"/>
+              </a:rPr>
+              <a:t>(x=470, n=1000, p=1/2, alternative='less')  </a:t>
+            </a:r>
+            <a:r>
+              <a:rPr lang="en-US" sz="1200" b="1" dirty="0">
+                <a:solidFill>
+                  <a:srgbClr val="00B050"/>
+                </a:solidFill>
+                <a:latin typeface="Consolas" panose="020B0609020204030204" pitchFamily="49" charset="0"/>
+                <a:cs typeface="Consolas" panose="020B0609020204030204" pitchFamily="49" charset="0"/>
+              </a:rPr>
+              <a:t># 0.973</a:t>
+            </a:r>
+          </a:p>
+          <a:p>
+            <a:r>
+              <a:rPr lang="en-US" sz="1200" b="1" dirty="0" err="1">
+                <a:solidFill>
+                  <a:srgbClr val="0070C0"/>
+                </a:solidFill>
+                <a:latin typeface="Consolas" panose="020B0609020204030204" pitchFamily="49" charset="0"/>
+                <a:cs typeface="Consolas" panose="020B0609020204030204" pitchFamily="49" charset="0"/>
+              </a:rPr>
+              <a:t>binom_test</a:t>
+            </a:r>
+            <a:r>
+              <a:rPr lang="en-US" sz="1200" b="1" dirty="0">
+                <a:solidFill>
+                  <a:srgbClr val="0070C0"/>
+                </a:solidFill>
+                <a:latin typeface="Consolas" panose="020B0609020204030204" pitchFamily="49" charset="0"/>
+                <a:cs typeface="Consolas" panose="020B0609020204030204" pitchFamily="49" charset="0"/>
+              </a:rPr>
+              <a:t>(x=500, n=1000, p=1/2, alternative='less')  </a:t>
+            </a:r>
+            <a:r>
+              <a:rPr lang="en-US" sz="1200" b="1" dirty="0">
+                <a:solidFill>
+                  <a:srgbClr val="00B050"/>
+                </a:solidFill>
+                <a:latin typeface="Consolas" panose="020B0609020204030204" pitchFamily="49" charset="0"/>
+                <a:cs typeface="Consolas" panose="020B0609020204030204" pitchFamily="49" charset="0"/>
+              </a:rPr>
+              <a:t># 0.5</a:t>
+            </a:r>
+          </a:p>
+          <a:p>
+            <a:r>
+              <a:rPr lang="en-US" sz="1200" b="1" dirty="0" err="1">
+                <a:solidFill>
+                  <a:srgbClr val="0070C0"/>
+                </a:solidFill>
+                <a:latin typeface="Consolas" panose="020B0609020204030204" pitchFamily="49" charset="0"/>
+                <a:cs typeface="Consolas" panose="020B0609020204030204" pitchFamily="49" charset="0"/>
+              </a:rPr>
+              <a:t>binom_test</a:t>
+            </a:r>
+            <a:r>
+              <a:rPr lang="en-US" sz="1200" b="1" dirty="0">
+                <a:solidFill>
+                  <a:srgbClr val="0070C0"/>
+                </a:solidFill>
+                <a:latin typeface="Consolas" panose="020B0609020204030204" pitchFamily="49" charset="0"/>
+                <a:cs typeface="Consolas" panose="020B0609020204030204" pitchFamily="49" charset="0"/>
+              </a:rPr>
+              <a:t>(x=530, n=1000, p=1/2, alternative='less')  </a:t>
+            </a:r>
+            <a:r>
+              <a:rPr lang="en-US" sz="1200" b="1" dirty="0">
+                <a:solidFill>
+                  <a:srgbClr val="00B050"/>
+                </a:solidFill>
+                <a:latin typeface="Consolas" panose="020B0609020204030204" pitchFamily="49" charset="0"/>
+                <a:cs typeface="Consolas" panose="020B0609020204030204" pitchFamily="49" charset="0"/>
+              </a:rPr>
+              <a:t># 0.031</a:t>
+            </a:r>
+          </a:p>
+          <a:p>
+            <a:r>
+              <a:rPr lang="en-US" sz="1200" b="1" dirty="0" err="1">
+                <a:solidFill>
+                  <a:srgbClr val="0070C0"/>
+                </a:solidFill>
+                <a:latin typeface="Consolas" panose="020B0609020204030204" pitchFamily="49" charset="0"/>
+                <a:cs typeface="Consolas" panose="020B0609020204030204" pitchFamily="49" charset="0"/>
+              </a:rPr>
+              <a:t>binom_test</a:t>
+            </a:r>
+            <a:r>
+              <a:rPr lang="en-US" sz="1200" b="1" dirty="0">
+                <a:solidFill>
+                  <a:srgbClr val="0070C0"/>
+                </a:solidFill>
+                <a:latin typeface="Consolas" panose="020B0609020204030204" pitchFamily="49" charset="0"/>
+                <a:cs typeface="Consolas" panose="020B0609020204030204" pitchFamily="49" charset="0"/>
+              </a:rPr>
+              <a:t>(x=999, n=1000, p=1/2, alternative='less')  </a:t>
+            </a:r>
+            <a:r>
+              <a:rPr lang="en-US" sz="1200" b="1" dirty="0">
+                <a:solidFill>
+                  <a:srgbClr val="00B050"/>
+                </a:solidFill>
+                <a:latin typeface="Consolas" panose="020B0609020204030204" pitchFamily="49" charset="0"/>
+                <a:cs typeface="Consolas" panose="020B0609020204030204" pitchFamily="49" charset="0"/>
+              </a:rPr>
+              <a:t># 0</a:t>
+            </a:r>
           </a:p>
         </p:txBody>
       </p:sp>
@@ -18641,6 +19228,743 @@
 </file>
 
 <file path=ppt/slides/slide5.xml><?xml version="1.0" encoding="utf-8"?>
+<p:sld xmlns:a="http://schemas.openxmlformats.org/drawingml/2006/main" xmlns:r="http://schemas.openxmlformats.org/officeDocument/2006/relationships" xmlns:p="http://schemas.openxmlformats.org/presentationml/2006/main">
+  <p:cSld>
+    <p:spTree>
+      <p:nvGrpSpPr>
+        <p:cNvPr id="1" name=""/>
+        <p:cNvGrpSpPr/>
+        <p:nvPr/>
+      </p:nvGrpSpPr>
+      <p:grpSpPr>
+        <a:xfrm>
+          <a:off x="0" y="0"/>
+          <a:ext cx="0" cy="0"/>
+          <a:chOff x="0" y="0"/>
+          <a:chExt cx="0" cy="0"/>
+        </a:xfrm>
+      </p:grpSpPr>
+      <p:sp>
+        <p:nvSpPr>
+          <p:cNvPr id="4" name="TextBox 3">
+            <a:extLst>
+              <a:ext uri="{FF2B5EF4-FFF2-40B4-BE49-F238E27FC236}">
+                <a16:creationId xmlns:a16="http://schemas.microsoft.com/office/drawing/2014/main" id="{1E4E77F6-2D57-344D-957A-D121D2D97481}"/>
+              </a:ext>
+            </a:extLst>
+          </p:cNvPr>
+          <p:cNvSpPr txBox="1"/>
+          <p:nvPr/>
+        </p:nvSpPr>
+        <p:spPr>
+          <a:xfrm>
+            <a:off x="345688" y="1186087"/>
+            <a:ext cx="3869473" cy="3970318"/>
+          </a:xfrm>
+          <a:prstGeom prst="rect">
+            <a:avLst/>
+          </a:prstGeom>
+          <a:noFill/>
+        </p:spPr>
+        <p:txBody>
+          <a:bodyPr wrap="square" rtlCol="0">
+            <a:spAutoFit/>
+          </a:bodyPr>
+          <a:lstStyle/>
+          <a:p>
+            <a:r>
+              <a:rPr lang="en-US" sz="1200" dirty="0">
+                <a:solidFill>
+                  <a:srgbClr val="0070C0"/>
+                </a:solidFill>
+                <a:latin typeface="Menlo" panose="020B0609030804020204" pitchFamily="49" charset="0"/>
+                <a:ea typeface="Menlo" panose="020B0609030804020204" pitchFamily="49" charset="0"/>
+                <a:cs typeface="Menlo" panose="020B0609030804020204" pitchFamily="49" charset="0"/>
+              </a:rPr>
+              <a:t>import </a:t>
+            </a:r>
+            <a:r>
+              <a:rPr lang="en-US" sz="1200" dirty="0" err="1">
+                <a:solidFill>
+                  <a:srgbClr val="0070C0"/>
+                </a:solidFill>
+                <a:latin typeface="Menlo" panose="020B0609030804020204" pitchFamily="49" charset="0"/>
+                <a:ea typeface="Menlo" panose="020B0609030804020204" pitchFamily="49" charset="0"/>
+                <a:cs typeface="Menlo" panose="020B0609030804020204" pitchFamily="49" charset="0"/>
+              </a:rPr>
+              <a:t>os</a:t>
+            </a:r>
+            <a:r>
+              <a:rPr lang="en-US" sz="1200" dirty="0">
+                <a:solidFill>
+                  <a:srgbClr val="0070C0"/>
+                </a:solidFill>
+                <a:latin typeface="Menlo" panose="020B0609030804020204" pitchFamily="49" charset="0"/>
+                <a:ea typeface="Menlo" panose="020B0609030804020204" pitchFamily="49" charset="0"/>
+                <a:cs typeface="Menlo" panose="020B0609030804020204" pitchFamily="49" charset="0"/>
+              </a:rPr>
+              <a:t>, sys, math</a:t>
+            </a:r>
+          </a:p>
+          <a:p>
+            <a:r>
+              <a:rPr lang="en-US" sz="1200" dirty="0">
+                <a:solidFill>
+                  <a:srgbClr val="0070C0"/>
+                </a:solidFill>
+                <a:latin typeface="Menlo" panose="020B0609030804020204" pitchFamily="49" charset="0"/>
+                <a:ea typeface="Menlo" panose="020B0609030804020204" pitchFamily="49" charset="0"/>
+                <a:cs typeface="Menlo" panose="020B0609030804020204" pitchFamily="49" charset="0"/>
+              </a:rPr>
+              <a:t>from </a:t>
+            </a:r>
+            <a:r>
+              <a:rPr lang="en-US" sz="1200" dirty="0" err="1">
+                <a:solidFill>
+                  <a:srgbClr val="0070C0"/>
+                </a:solidFill>
+                <a:latin typeface="Menlo" panose="020B0609030804020204" pitchFamily="49" charset="0"/>
+                <a:ea typeface="Menlo" panose="020B0609030804020204" pitchFamily="49" charset="0"/>
+                <a:cs typeface="Menlo" panose="020B0609030804020204" pitchFamily="49" charset="0"/>
+              </a:rPr>
+              <a:t>scipy.stats</a:t>
+            </a:r>
+            <a:r>
+              <a:rPr lang="en-US" sz="1200" dirty="0">
+                <a:solidFill>
+                  <a:srgbClr val="0070C0"/>
+                </a:solidFill>
+                <a:latin typeface="Menlo" panose="020B0609030804020204" pitchFamily="49" charset="0"/>
+                <a:ea typeface="Menlo" panose="020B0609030804020204" pitchFamily="49" charset="0"/>
+                <a:cs typeface="Menlo" panose="020B0609030804020204" pitchFamily="49" charset="0"/>
+              </a:rPr>
+              <a:t> import </a:t>
+            </a:r>
+            <a:r>
+              <a:rPr lang="en-US" sz="1200" dirty="0" err="1">
+                <a:solidFill>
+                  <a:srgbClr val="0070C0"/>
+                </a:solidFill>
+                <a:latin typeface="Menlo" panose="020B0609030804020204" pitchFamily="49" charset="0"/>
+                <a:ea typeface="Menlo" panose="020B0609030804020204" pitchFamily="49" charset="0"/>
+                <a:cs typeface="Menlo" panose="020B0609030804020204" pitchFamily="49" charset="0"/>
+              </a:rPr>
+              <a:t>binom_test</a:t>
+            </a:r>
+            <a:endParaRPr lang="en-US" sz="1200" dirty="0">
+              <a:solidFill>
+                <a:srgbClr val="0070C0"/>
+              </a:solidFill>
+              <a:latin typeface="Menlo" panose="020B0609030804020204" pitchFamily="49" charset="0"/>
+              <a:ea typeface="Menlo" panose="020B0609030804020204" pitchFamily="49" charset="0"/>
+              <a:cs typeface="Menlo" panose="020B0609030804020204" pitchFamily="49" charset="0"/>
+            </a:endParaRPr>
+          </a:p>
+          <a:p>
+            <a:r>
+              <a:rPr lang="en-US" sz="1200" dirty="0">
+                <a:solidFill>
+                  <a:srgbClr val="0070C0"/>
+                </a:solidFill>
+                <a:latin typeface="Menlo" panose="020B0609030804020204" pitchFamily="49" charset="0"/>
+                <a:ea typeface="Menlo" panose="020B0609030804020204" pitchFamily="49" charset="0"/>
+                <a:cs typeface="Menlo" panose="020B0609030804020204" pitchFamily="49" charset="0"/>
+              </a:rPr>
+              <a:t>import </a:t>
+            </a:r>
+            <a:r>
+              <a:rPr lang="en-US" sz="1200" dirty="0" err="1">
+                <a:solidFill>
+                  <a:srgbClr val="0070C0"/>
+                </a:solidFill>
+                <a:latin typeface="Menlo" panose="020B0609030804020204" pitchFamily="49" charset="0"/>
+                <a:ea typeface="Menlo" panose="020B0609030804020204" pitchFamily="49" charset="0"/>
+                <a:cs typeface="Menlo" panose="020B0609030804020204" pitchFamily="49" charset="0"/>
+              </a:rPr>
+              <a:t>matplotlib.pyplot</a:t>
+            </a:r>
+            <a:r>
+              <a:rPr lang="en-US" sz="1200" dirty="0">
+                <a:solidFill>
+                  <a:srgbClr val="0070C0"/>
+                </a:solidFill>
+                <a:latin typeface="Menlo" panose="020B0609030804020204" pitchFamily="49" charset="0"/>
+                <a:ea typeface="Menlo" panose="020B0609030804020204" pitchFamily="49" charset="0"/>
+                <a:cs typeface="Menlo" panose="020B0609030804020204" pitchFamily="49" charset="0"/>
+              </a:rPr>
+              <a:t> as </a:t>
+            </a:r>
+            <a:r>
+              <a:rPr lang="en-US" sz="1200" dirty="0" err="1">
+                <a:solidFill>
+                  <a:srgbClr val="0070C0"/>
+                </a:solidFill>
+                <a:latin typeface="Menlo" panose="020B0609030804020204" pitchFamily="49" charset="0"/>
+                <a:ea typeface="Menlo" panose="020B0609030804020204" pitchFamily="49" charset="0"/>
+                <a:cs typeface="Menlo" panose="020B0609030804020204" pitchFamily="49" charset="0"/>
+              </a:rPr>
+              <a:t>plt</a:t>
+            </a:r>
+            <a:endParaRPr lang="en-US" sz="1200" dirty="0">
+              <a:solidFill>
+                <a:srgbClr val="0070C0"/>
+              </a:solidFill>
+              <a:latin typeface="Menlo" panose="020B0609030804020204" pitchFamily="49" charset="0"/>
+              <a:ea typeface="Menlo" panose="020B0609030804020204" pitchFamily="49" charset="0"/>
+              <a:cs typeface="Menlo" panose="020B0609030804020204" pitchFamily="49" charset="0"/>
+            </a:endParaRPr>
+          </a:p>
+          <a:p>
+            <a:r>
+              <a:rPr lang="en-US" sz="1200" dirty="0">
+                <a:solidFill>
+                  <a:srgbClr val="0070C0"/>
+                </a:solidFill>
+                <a:latin typeface="Menlo" panose="020B0609030804020204" pitchFamily="49" charset="0"/>
+                <a:ea typeface="Menlo" panose="020B0609030804020204" pitchFamily="49" charset="0"/>
+                <a:cs typeface="Menlo" panose="020B0609030804020204" pitchFamily="49" charset="0"/>
+              </a:rPr>
+              <a:t>xx  = []</a:t>
+            </a:r>
+          </a:p>
+          <a:p>
+            <a:r>
+              <a:rPr lang="en-US" sz="1200" dirty="0" err="1">
+                <a:solidFill>
+                  <a:srgbClr val="0070C0"/>
+                </a:solidFill>
+                <a:latin typeface="Menlo" panose="020B0609030804020204" pitchFamily="49" charset="0"/>
+                <a:ea typeface="Menlo" panose="020B0609030804020204" pitchFamily="49" charset="0"/>
+                <a:cs typeface="Menlo" panose="020B0609030804020204" pitchFamily="49" charset="0"/>
+              </a:rPr>
+              <a:t>yy</a:t>
+            </a:r>
+            <a:r>
+              <a:rPr lang="en-US" sz="1200" dirty="0">
+                <a:solidFill>
+                  <a:srgbClr val="0070C0"/>
+                </a:solidFill>
+                <a:latin typeface="Menlo" panose="020B0609030804020204" pitchFamily="49" charset="0"/>
+                <a:ea typeface="Menlo" panose="020B0609030804020204" pitchFamily="49" charset="0"/>
+                <a:cs typeface="Menlo" panose="020B0609030804020204" pitchFamily="49" charset="0"/>
+              </a:rPr>
+              <a:t>  = []</a:t>
+            </a:r>
+          </a:p>
+          <a:p>
+            <a:r>
+              <a:rPr lang="en-US" sz="1200" dirty="0">
+                <a:solidFill>
+                  <a:srgbClr val="0070C0"/>
+                </a:solidFill>
+                <a:latin typeface="Menlo" panose="020B0609030804020204" pitchFamily="49" charset="0"/>
+                <a:ea typeface="Menlo" panose="020B0609030804020204" pitchFamily="49" charset="0"/>
+                <a:cs typeface="Menlo" panose="020B0609030804020204" pitchFamily="49" charset="0"/>
+              </a:rPr>
+              <a:t>yy2 = []</a:t>
+            </a:r>
+          </a:p>
+          <a:p>
+            <a:endParaRPr lang="en-US" sz="1200" dirty="0">
+              <a:solidFill>
+                <a:srgbClr val="0070C0"/>
+              </a:solidFill>
+              <a:latin typeface="Menlo" panose="020B0609030804020204" pitchFamily="49" charset="0"/>
+              <a:ea typeface="Menlo" panose="020B0609030804020204" pitchFamily="49" charset="0"/>
+              <a:cs typeface="Menlo" panose="020B0609030804020204" pitchFamily="49" charset="0"/>
+            </a:endParaRPr>
+          </a:p>
+          <a:p>
+            <a:r>
+              <a:rPr lang="en-US" sz="1200" dirty="0">
+                <a:solidFill>
+                  <a:srgbClr val="0070C0"/>
+                </a:solidFill>
+                <a:latin typeface="Menlo" panose="020B0609030804020204" pitchFamily="49" charset="0"/>
+                <a:ea typeface="Menlo" panose="020B0609030804020204" pitchFamily="49" charset="0"/>
+                <a:cs typeface="Menlo" panose="020B0609030804020204" pitchFamily="49" charset="0"/>
+              </a:rPr>
+              <a:t>sigma = </a:t>
+            </a:r>
+            <a:r>
+              <a:rPr lang="en-US" sz="1200" dirty="0" err="1">
+                <a:solidFill>
+                  <a:srgbClr val="0070C0"/>
+                </a:solidFill>
+                <a:latin typeface="Menlo" panose="020B0609030804020204" pitchFamily="49" charset="0"/>
+                <a:ea typeface="Menlo" panose="020B0609030804020204" pitchFamily="49" charset="0"/>
+                <a:cs typeface="Menlo" panose="020B0609030804020204" pitchFamily="49" charset="0"/>
+              </a:rPr>
+              <a:t>math.sqrt</a:t>
+            </a:r>
+            <a:r>
+              <a:rPr lang="en-US" sz="1200" dirty="0">
+                <a:solidFill>
+                  <a:srgbClr val="0070C0"/>
+                </a:solidFill>
+                <a:latin typeface="Menlo" panose="020B0609030804020204" pitchFamily="49" charset="0"/>
+                <a:ea typeface="Menlo" panose="020B0609030804020204" pitchFamily="49" charset="0"/>
+                <a:cs typeface="Menlo" panose="020B0609030804020204" pitchFamily="49" charset="0"/>
+              </a:rPr>
+              <a:t>(5000)/2.0</a:t>
+            </a:r>
+          </a:p>
+          <a:p>
+            <a:r>
+              <a:rPr lang="en-US" sz="1200" dirty="0">
+                <a:solidFill>
+                  <a:srgbClr val="0070C0"/>
+                </a:solidFill>
+                <a:latin typeface="Menlo" panose="020B0609030804020204" pitchFamily="49" charset="0"/>
+                <a:ea typeface="Menlo" panose="020B0609030804020204" pitchFamily="49" charset="0"/>
+                <a:cs typeface="Menlo" panose="020B0609030804020204" pitchFamily="49" charset="0"/>
+              </a:rPr>
+              <a:t>v1 = 2500-sigma</a:t>
+            </a:r>
+          </a:p>
+          <a:p>
+            <a:r>
+              <a:rPr lang="en-US" sz="1200" dirty="0">
+                <a:solidFill>
+                  <a:srgbClr val="0070C0"/>
+                </a:solidFill>
+                <a:latin typeface="Menlo" panose="020B0609030804020204" pitchFamily="49" charset="0"/>
+                <a:ea typeface="Menlo" panose="020B0609030804020204" pitchFamily="49" charset="0"/>
+                <a:cs typeface="Menlo" panose="020B0609030804020204" pitchFamily="49" charset="0"/>
+              </a:rPr>
+              <a:t>v2 = 2500+sigma</a:t>
+            </a:r>
+          </a:p>
+          <a:p>
+            <a:r>
+              <a:rPr lang="en-US" sz="1200" dirty="0">
+                <a:solidFill>
+                  <a:srgbClr val="0070C0"/>
+                </a:solidFill>
+                <a:latin typeface="Menlo" panose="020B0609030804020204" pitchFamily="49" charset="0"/>
+                <a:ea typeface="Menlo" panose="020B0609030804020204" pitchFamily="49" charset="0"/>
+                <a:cs typeface="Menlo" panose="020B0609030804020204" pitchFamily="49" charset="0"/>
+              </a:rPr>
+              <a:t>print(v1,v2)    </a:t>
+            </a:r>
+            <a:r>
+              <a:rPr lang="en-US" sz="1200" dirty="0">
+                <a:solidFill>
+                  <a:srgbClr val="00B050"/>
+                </a:solidFill>
+                <a:latin typeface="Menlo" panose="020B0609030804020204" pitchFamily="49" charset="0"/>
+                <a:ea typeface="Menlo" panose="020B0609030804020204" pitchFamily="49" charset="0"/>
+                <a:cs typeface="Menlo" panose="020B0609030804020204" pitchFamily="49" charset="0"/>
+              </a:rPr>
+              <a:t># 2464.64, 2535.36</a:t>
+            </a:r>
+          </a:p>
+          <a:p>
+            <a:endParaRPr lang="en-US" sz="1200" dirty="0">
+              <a:solidFill>
+                <a:srgbClr val="0070C0"/>
+              </a:solidFill>
+              <a:latin typeface="Menlo" panose="020B0609030804020204" pitchFamily="49" charset="0"/>
+              <a:ea typeface="Menlo" panose="020B0609030804020204" pitchFamily="49" charset="0"/>
+              <a:cs typeface="Menlo" panose="020B0609030804020204" pitchFamily="49" charset="0"/>
+            </a:endParaRPr>
+          </a:p>
+          <a:p>
+            <a:r>
+              <a:rPr lang="en-US" sz="1200" dirty="0">
+                <a:solidFill>
+                  <a:srgbClr val="0070C0"/>
+                </a:solidFill>
+                <a:latin typeface="Menlo" panose="020B0609030804020204" pitchFamily="49" charset="0"/>
+                <a:ea typeface="Menlo" panose="020B0609030804020204" pitchFamily="49" charset="0"/>
+                <a:cs typeface="Menlo" panose="020B0609030804020204" pitchFamily="49" charset="0"/>
+              </a:rPr>
+              <a:t>for ii in range (2300, 2700):</a:t>
+            </a:r>
+          </a:p>
+          <a:p>
+            <a:r>
+              <a:rPr lang="en-US" sz="1200" dirty="0">
+                <a:solidFill>
+                  <a:srgbClr val="0070C0"/>
+                </a:solidFill>
+                <a:latin typeface="Menlo" panose="020B0609030804020204" pitchFamily="49" charset="0"/>
+                <a:ea typeface="Menlo" panose="020B0609030804020204" pitchFamily="49" charset="0"/>
+                <a:cs typeface="Menlo" panose="020B0609030804020204" pitchFamily="49" charset="0"/>
+              </a:rPr>
+              <a:t>    </a:t>
+            </a:r>
+            <a:r>
+              <a:rPr lang="en-US" sz="1200" dirty="0" err="1">
+                <a:solidFill>
+                  <a:srgbClr val="0070C0"/>
+                </a:solidFill>
+                <a:latin typeface="Menlo" panose="020B0609030804020204" pitchFamily="49" charset="0"/>
+                <a:ea typeface="Menlo" panose="020B0609030804020204" pitchFamily="49" charset="0"/>
+                <a:cs typeface="Menlo" panose="020B0609030804020204" pitchFamily="49" charset="0"/>
+              </a:rPr>
+              <a:t>xx.append</a:t>
+            </a:r>
+            <a:r>
+              <a:rPr lang="en-US" sz="1200" dirty="0">
+                <a:solidFill>
+                  <a:srgbClr val="0070C0"/>
+                </a:solidFill>
+                <a:latin typeface="Menlo" panose="020B0609030804020204" pitchFamily="49" charset="0"/>
+                <a:ea typeface="Menlo" panose="020B0609030804020204" pitchFamily="49" charset="0"/>
+                <a:cs typeface="Menlo" panose="020B0609030804020204" pitchFamily="49" charset="0"/>
+              </a:rPr>
+              <a:t>(ii)</a:t>
+            </a:r>
+          </a:p>
+          <a:p>
+            <a:r>
+              <a:rPr lang="en-US" sz="1200" dirty="0">
+                <a:solidFill>
+                  <a:srgbClr val="0070C0"/>
+                </a:solidFill>
+                <a:latin typeface="Menlo" panose="020B0609030804020204" pitchFamily="49" charset="0"/>
+                <a:ea typeface="Menlo" panose="020B0609030804020204" pitchFamily="49" charset="0"/>
+                <a:cs typeface="Menlo" panose="020B0609030804020204" pitchFamily="49" charset="0"/>
+              </a:rPr>
+              <a:t>    </a:t>
+            </a:r>
+            <a:r>
+              <a:rPr lang="en-US" sz="1200" dirty="0" err="1">
+                <a:solidFill>
+                  <a:srgbClr val="0070C0"/>
+                </a:solidFill>
+                <a:latin typeface="Menlo" panose="020B0609030804020204" pitchFamily="49" charset="0"/>
+                <a:ea typeface="Menlo" panose="020B0609030804020204" pitchFamily="49" charset="0"/>
+                <a:cs typeface="Menlo" panose="020B0609030804020204" pitchFamily="49" charset="0"/>
+              </a:rPr>
+              <a:t>yy.append</a:t>
+            </a:r>
+            <a:r>
+              <a:rPr lang="en-US" sz="1200" dirty="0">
+                <a:solidFill>
+                  <a:srgbClr val="0070C0"/>
+                </a:solidFill>
+                <a:latin typeface="Menlo" panose="020B0609030804020204" pitchFamily="49" charset="0"/>
+                <a:ea typeface="Menlo" panose="020B0609030804020204" pitchFamily="49" charset="0"/>
+                <a:cs typeface="Menlo" panose="020B0609030804020204" pitchFamily="49" charset="0"/>
+              </a:rPr>
+              <a:t>(</a:t>
+            </a:r>
+            <a:r>
+              <a:rPr lang="en-US" sz="1200" dirty="0" err="1">
+                <a:solidFill>
+                  <a:srgbClr val="0070C0"/>
+                </a:solidFill>
+                <a:latin typeface="Menlo" panose="020B0609030804020204" pitchFamily="49" charset="0"/>
+                <a:ea typeface="Menlo" panose="020B0609030804020204" pitchFamily="49" charset="0"/>
+                <a:cs typeface="Menlo" panose="020B0609030804020204" pitchFamily="49" charset="0"/>
+              </a:rPr>
+              <a:t>binom.pmf</a:t>
+            </a:r>
+            <a:r>
+              <a:rPr lang="en-US" sz="1200" dirty="0">
+                <a:solidFill>
+                  <a:srgbClr val="0070C0"/>
+                </a:solidFill>
+                <a:latin typeface="Menlo" panose="020B0609030804020204" pitchFamily="49" charset="0"/>
+                <a:ea typeface="Menlo" panose="020B0609030804020204" pitchFamily="49" charset="0"/>
+                <a:cs typeface="Menlo" panose="020B0609030804020204" pitchFamily="49" charset="0"/>
+              </a:rPr>
+              <a:t>(ii,5000,0.5))</a:t>
+            </a:r>
+          </a:p>
+          <a:p>
+            <a:r>
+              <a:rPr lang="en-US" sz="1200" dirty="0">
+                <a:solidFill>
+                  <a:srgbClr val="0070C0"/>
+                </a:solidFill>
+                <a:latin typeface="Menlo" panose="020B0609030804020204" pitchFamily="49" charset="0"/>
+                <a:ea typeface="Menlo" panose="020B0609030804020204" pitchFamily="49" charset="0"/>
+                <a:cs typeface="Menlo" panose="020B0609030804020204" pitchFamily="49" charset="0"/>
+              </a:rPr>
+              <a:t>    </a:t>
+            </a:r>
+            <a:r>
+              <a:rPr lang="en-US" sz="1200" dirty="0" err="1">
+                <a:solidFill>
+                  <a:srgbClr val="0070C0"/>
+                </a:solidFill>
+                <a:latin typeface="Menlo" panose="020B0609030804020204" pitchFamily="49" charset="0"/>
+                <a:ea typeface="Menlo" panose="020B0609030804020204" pitchFamily="49" charset="0"/>
+                <a:cs typeface="Menlo" panose="020B0609030804020204" pitchFamily="49" charset="0"/>
+              </a:rPr>
+              <a:t>val</a:t>
+            </a:r>
+            <a:r>
+              <a:rPr lang="en-US" sz="1200" dirty="0">
+                <a:solidFill>
+                  <a:srgbClr val="0070C0"/>
+                </a:solidFill>
+                <a:latin typeface="Menlo" panose="020B0609030804020204" pitchFamily="49" charset="0"/>
+                <a:ea typeface="Menlo" panose="020B0609030804020204" pitchFamily="49" charset="0"/>
+                <a:cs typeface="Menlo" panose="020B0609030804020204" pitchFamily="49" charset="0"/>
+              </a:rPr>
+              <a:t> = 0.0</a:t>
+            </a:r>
+          </a:p>
+          <a:p>
+            <a:r>
+              <a:rPr lang="en-US" sz="1200" dirty="0">
+                <a:solidFill>
+                  <a:srgbClr val="0070C0"/>
+                </a:solidFill>
+                <a:latin typeface="Menlo" panose="020B0609030804020204" pitchFamily="49" charset="0"/>
+                <a:ea typeface="Menlo" panose="020B0609030804020204" pitchFamily="49" charset="0"/>
+                <a:cs typeface="Menlo" panose="020B0609030804020204" pitchFamily="49" charset="0"/>
+              </a:rPr>
+              <a:t>    if v1 &lt;= ii &lt;= v2:</a:t>
+            </a:r>
+          </a:p>
+          <a:p>
+            <a:r>
+              <a:rPr lang="en-US" sz="1200" dirty="0">
+                <a:solidFill>
+                  <a:srgbClr val="0070C0"/>
+                </a:solidFill>
+                <a:latin typeface="Menlo" panose="020B0609030804020204" pitchFamily="49" charset="0"/>
+                <a:ea typeface="Menlo" panose="020B0609030804020204" pitchFamily="49" charset="0"/>
+                <a:cs typeface="Menlo" panose="020B0609030804020204" pitchFamily="49" charset="0"/>
+              </a:rPr>
+              <a:t>        </a:t>
+            </a:r>
+            <a:r>
+              <a:rPr lang="en-US" sz="1200" dirty="0" err="1">
+                <a:solidFill>
+                  <a:srgbClr val="0070C0"/>
+                </a:solidFill>
+                <a:latin typeface="Menlo" panose="020B0609030804020204" pitchFamily="49" charset="0"/>
+                <a:ea typeface="Menlo" panose="020B0609030804020204" pitchFamily="49" charset="0"/>
+                <a:cs typeface="Menlo" panose="020B0609030804020204" pitchFamily="49" charset="0"/>
+              </a:rPr>
+              <a:t>val</a:t>
+            </a:r>
+            <a:r>
+              <a:rPr lang="en-US" sz="1200" dirty="0">
+                <a:solidFill>
+                  <a:srgbClr val="0070C0"/>
+                </a:solidFill>
+                <a:latin typeface="Menlo" panose="020B0609030804020204" pitchFamily="49" charset="0"/>
+                <a:ea typeface="Menlo" panose="020B0609030804020204" pitchFamily="49" charset="0"/>
+                <a:cs typeface="Menlo" panose="020B0609030804020204" pitchFamily="49" charset="0"/>
+              </a:rPr>
+              <a:t> = 0.01</a:t>
+            </a:r>
+          </a:p>
+          <a:p>
+            <a:r>
+              <a:rPr lang="en-US" sz="1200" dirty="0">
+                <a:solidFill>
+                  <a:srgbClr val="0070C0"/>
+                </a:solidFill>
+                <a:latin typeface="Menlo" panose="020B0609030804020204" pitchFamily="49" charset="0"/>
+                <a:ea typeface="Menlo" panose="020B0609030804020204" pitchFamily="49" charset="0"/>
+                <a:cs typeface="Menlo" panose="020B0609030804020204" pitchFamily="49" charset="0"/>
+              </a:rPr>
+              <a:t>    yy2.append(</a:t>
+            </a:r>
+            <a:r>
+              <a:rPr lang="en-US" sz="1200" dirty="0" err="1">
+                <a:solidFill>
+                  <a:srgbClr val="0070C0"/>
+                </a:solidFill>
+                <a:latin typeface="Menlo" panose="020B0609030804020204" pitchFamily="49" charset="0"/>
+                <a:ea typeface="Menlo" panose="020B0609030804020204" pitchFamily="49" charset="0"/>
+                <a:cs typeface="Menlo" panose="020B0609030804020204" pitchFamily="49" charset="0"/>
+              </a:rPr>
+              <a:t>val</a:t>
+            </a:r>
+            <a:r>
+              <a:rPr lang="en-US" sz="1200" dirty="0">
+                <a:solidFill>
+                  <a:srgbClr val="0070C0"/>
+                </a:solidFill>
+                <a:latin typeface="Menlo" panose="020B0609030804020204" pitchFamily="49" charset="0"/>
+                <a:ea typeface="Menlo" panose="020B0609030804020204" pitchFamily="49" charset="0"/>
+                <a:cs typeface="Menlo" panose="020B0609030804020204" pitchFamily="49" charset="0"/>
+              </a:rPr>
+              <a:t>)</a:t>
+            </a:r>
+          </a:p>
+          <a:p>
+            <a:r>
+              <a:rPr lang="en-US" sz="1200" dirty="0">
+                <a:solidFill>
+                  <a:srgbClr val="0070C0"/>
+                </a:solidFill>
+                <a:latin typeface="Menlo" panose="020B0609030804020204" pitchFamily="49" charset="0"/>
+                <a:ea typeface="Menlo" panose="020B0609030804020204" pitchFamily="49" charset="0"/>
+                <a:cs typeface="Menlo" panose="020B0609030804020204" pitchFamily="49" charset="0"/>
+              </a:rPr>
+              <a:t>_ = </a:t>
+            </a:r>
+            <a:r>
+              <a:rPr lang="en-US" sz="1200" dirty="0" err="1">
+                <a:solidFill>
+                  <a:srgbClr val="0070C0"/>
+                </a:solidFill>
+                <a:latin typeface="Menlo" panose="020B0609030804020204" pitchFamily="49" charset="0"/>
+                <a:ea typeface="Menlo" panose="020B0609030804020204" pitchFamily="49" charset="0"/>
+                <a:cs typeface="Menlo" panose="020B0609030804020204" pitchFamily="49" charset="0"/>
+              </a:rPr>
+              <a:t>plt.plot</a:t>
+            </a:r>
+            <a:r>
+              <a:rPr lang="en-US" sz="1200" dirty="0">
+                <a:solidFill>
+                  <a:srgbClr val="0070C0"/>
+                </a:solidFill>
+                <a:latin typeface="Menlo" panose="020B0609030804020204" pitchFamily="49" charset="0"/>
+                <a:ea typeface="Menlo" panose="020B0609030804020204" pitchFamily="49" charset="0"/>
+                <a:cs typeface="Menlo" panose="020B0609030804020204" pitchFamily="49" charset="0"/>
+              </a:rPr>
+              <a:t>(</a:t>
+            </a:r>
+            <a:r>
+              <a:rPr lang="en-US" sz="1200" dirty="0" err="1">
+                <a:solidFill>
+                  <a:srgbClr val="0070C0"/>
+                </a:solidFill>
+                <a:latin typeface="Menlo" panose="020B0609030804020204" pitchFamily="49" charset="0"/>
+                <a:ea typeface="Menlo" panose="020B0609030804020204" pitchFamily="49" charset="0"/>
+                <a:cs typeface="Menlo" panose="020B0609030804020204" pitchFamily="49" charset="0"/>
+              </a:rPr>
+              <a:t>xx,yy</a:t>
+            </a:r>
+            <a:r>
+              <a:rPr lang="en-US" sz="1200" dirty="0">
+                <a:solidFill>
+                  <a:srgbClr val="0070C0"/>
+                </a:solidFill>
+                <a:latin typeface="Menlo" panose="020B0609030804020204" pitchFamily="49" charset="0"/>
+                <a:ea typeface="Menlo" panose="020B0609030804020204" pitchFamily="49" charset="0"/>
+                <a:cs typeface="Menlo" panose="020B0609030804020204" pitchFamily="49" charset="0"/>
+              </a:rPr>
+              <a:t>)</a:t>
+            </a:r>
+          </a:p>
+          <a:p>
+            <a:r>
+              <a:rPr lang="en-US" sz="1200" dirty="0">
+                <a:solidFill>
+                  <a:srgbClr val="0070C0"/>
+                </a:solidFill>
+                <a:latin typeface="Menlo" panose="020B0609030804020204" pitchFamily="49" charset="0"/>
+                <a:ea typeface="Menlo" panose="020B0609030804020204" pitchFamily="49" charset="0"/>
+                <a:cs typeface="Menlo" panose="020B0609030804020204" pitchFamily="49" charset="0"/>
+              </a:rPr>
+              <a:t>_ = </a:t>
+            </a:r>
+            <a:r>
+              <a:rPr lang="en-US" sz="1200" dirty="0" err="1">
+                <a:solidFill>
+                  <a:srgbClr val="0070C0"/>
+                </a:solidFill>
+                <a:latin typeface="Menlo" panose="020B0609030804020204" pitchFamily="49" charset="0"/>
+                <a:ea typeface="Menlo" panose="020B0609030804020204" pitchFamily="49" charset="0"/>
+                <a:cs typeface="Menlo" panose="020B0609030804020204" pitchFamily="49" charset="0"/>
+              </a:rPr>
+              <a:t>plt.plot</a:t>
+            </a:r>
+            <a:r>
+              <a:rPr lang="en-US" sz="1200" dirty="0">
+                <a:solidFill>
+                  <a:srgbClr val="0070C0"/>
+                </a:solidFill>
+                <a:latin typeface="Menlo" panose="020B0609030804020204" pitchFamily="49" charset="0"/>
+                <a:ea typeface="Menlo" panose="020B0609030804020204" pitchFamily="49" charset="0"/>
+                <a:cs typeface="Menlo" panose="020B0609030804020204" pitchFamily="49" charset="0"/>
+              </a:rPr>
+              <a:t>(xx,yy2) # show sigma range</a:t>
+            </a:r>
+          </a:p>
+        </p:txBody>
+      </p:sp>
+      <p:pic>
+        <p:nvPicPr>
+          <p:cNvPr id="5" name="Picture 4">
+            <a:extLst>
+              <a:ext uri="{FF2B5EF4-FFF2-40B4-BE49-F238E27FC236}">
+                <a16:creationId xmlns:a16="http://schemas.microsoft.com/office/drawing/2014/main" id="{2946C5B3-4D05-D54B-8D93-DB43DC8E13DE}"/>
+              </a:ext>
+            </a:extLst>
+          </p:cNvPr>
+          <p:cNvPicPr>
+            <a:picLocks noChangeAspect="1"/>
+          </p:cNvPicPr>
+          <p:nvPr/>
+        </p:nvPicPr>
+        <p:blipFill>
+          <a:blip r:embed="rId2"/>
+          <a:stretch>
+            <a:fillRect/>
+          </a:stretch>
+        </p:blipFill>
+        <p:spPr>
+          <a:xfrm>
+            <a:off x="4805626" y="1593590"/>
+            <a:ext cx="4876800" cy="3149600"/>
+          </a:xfrm>
+          <a:prstGeom prst="rect">
+            <a:avLst/>
+          </a:prstGeom>
+        </p:spPr>
+      </p:pic>
+      <p:sp>
+        <p:nvSpPr>
+          <p:cNvPr id="6" name="TextBox 5">
+            <a:extLst>
+              <a:ext uri="{FF2B5EF4-FFF2-40B4-BE49-F238E27FC236}">
+                <a16:creationId xmlns:a16="http://schemas.microsoft.com/office/drawing/2014/main" id="{6180DDB0-6998-994F-8A7D-E2271187FE2C}"/>
+              </a:ext>
+            </a:extLst>
+          </p:cNvPr>
+          <p:cNvSpPr txBox="1"/>
+          <p:nvPr/>
+        </p:nvSpPr>
+        <p:spPr>
+          <a:xfrm>
+            <a:off x="345688" y="156117"/>
+            <a:ext cx="6400800" cy="523220"/>
+          </a:xfrm>
+          <a:prstGeom prst="rect">
+            <a:avLst/>
+          </a:prstGeom>
+          <a:noFill/>
+        </p:spPr>
+        <p:txBody>
+          <a:bodyPr wrap="square" rtlCol="0">
+            <a:spAutoFit/>
+          </a:bodyPr>
+          <a:lstStyle/>
+          <a:p>
+            <a:r>
+              <a:rPr lang="en-US" sz="2800" b="1" dirty="0"/>
+              <a:t>Binomial Distribution – Plot, Sigma</a:t>
+            </a:r>
+          </a:p>
+        </p:txBody>
+      </p:sp>
+    </p:spTree>
+    <p:extLst>
+      <p:ext uri="{BB962C8B-B14F-4D97-AF65-F5344CB8AC3E}">
+        <p14:creationId xmlns:p14="http://schemas.microsoft.com/office/powerpoint/2010/main" val="180183310"/>
+      </p:ext>
+    </p:extLst>
+  </p:cSld>
+  <p:clrMapOvr>
+    <a:masterClrMapping/>
+  </p:clrMapOvr>
+</p:sld>
+</file>
+
+<file path=ppt/slides/slide6.xml><?xml version="1.0" encoding="utf-8"?>
 <p:sld xmlns:a="http://schemas.openxmlformats.org/drawingml/2006/main" xmlns:r="http://schemas.openxmlformats.org/officeDocument/2006/relationships" xmlns:p="http://schemas.openxmlformats.org/presentationml/2006/main">
   <p:cSld>
     <p:spTree>
@@ -19560,7 +20884,7 @@
 </p:sld>
 </file>
 
-<file path=ppt/slides/slide6.xml><?xml version="1.0" encoding="utf-8"?>
+<file path=ppt/slides/slide7.xml><?xml version="1.0" encoding="utf-8"?>
 <p:sld xmlns:a="http://schemas.openxmlformats.org/drawingml/2006/main" xmlns:r="http://schemas.openxmlformats.org/officeDocument/2006/relationships" xmlns:p="http://schemas.openxmlformats.org/presentationml/2006/main">
   <p:cSld>
     <p:spTree>
@@ -20540,7 +21864,7 @@
 </p:sld>
 </file>
 
-<file path=ppt/slides/slide7.xml><?xml version="1.0" encoding="utf-8"?>
+<file path=ppt/slides/slide8.xml><?xml version="1.0" encoding="utf-8"?>
 <p:sld xmlns:a="http://schemas.openxmlformats.org/drawingml/2006/main" xmlns:r="http://schemas.openxmlformats.org/officeDocument/2006/relationships" xmlns:p="http://schemas.openxmlformats.org/presentationml/2006/main">
   <p:cSld>
     <p:spTree>
@@ -21411,7 +22735,7 @@
 </p:sld>
 </file>
 
-<file path=ppt/slides/slide8.xml><?xml version="1.0" encoding="utf-8"?>
+<file path=ppt/slides/slide9.xml><?xml version="1.0" encoding="utf-8"?>
 <p:sld xmlns:a="http://schemas.openxmlformats.org/drawingml/2006/main" xmlns:r="http://schemas.openxmlformats.org/officeDocument/2006/relationships" xmlns:p="http://schemas.openxmlformats.org/presentationml/2006/main">
   <p:cSld>
     <p:spTree>

</xml_diff>